<commit_message>
docs: manuales y capacitaciones con capturas de pantalla reales (v1.1)
- 16 capturas de pantalla del sistema real agregadas a /public/manuales/imagenes/
- Manual Word actualizado con imágenes embebidas en cada sección (3.1 MB)
- 6 capacitaciones PPT actualizadas con slides de capturas:
  * Administrador: 14 slides con 9 capturas (1.3 MB)
  * Supervisor: 12 slides con 5 capturas (699 KB)
  * Usuario: 10 slides con 4 capturas (536 KB)
  * Personal: 9 slides con 3 capturas (449 KB)
  * Auditor: 9 slides con 4 capturas (525 KB)
  * Guardia: 9 slides con 2 capturas (776 KB)
- Versión actualizada a v1.1 en ManualesModule y manuales-guardia

Capturas incluidas:
01_login, 02_dashboard, 03_ot_listado, 04_proyectos, 05_rondas,
06_solicitudes_compra, 07_usuarios, 08_permisos, 09_manuales,
10_ot_crear, 11_sc_crear, 12_usuario_crear, 13_recuperar_password,
14_guardia_rondas, 15_guardia_manuales, 16_reset_password
</commit_message>
<xml_diff>
--- a/public/manuales/Capacitacion_Administrador.pptx
+++ b/public/manuales/Capacitacion_Administrador.pptx
@@ -17,6 +17,9 @@
     <p:sldId id="265" r:id="rId16"/>
     <p:sldId id="266" r:id="rId17"/>
     <p:sldId id="267" r:id="rId18"/>
+    <p:sldId id="268" r:id="rId19"/>
+    <p:sldId id="269" r:id="rId20"/>
+    <p:sldId id="270" r:id="rId21"/>
   </p:sldIdLst>
   <p:sldSz cx="12191695" cy="6858000" type="screen4x3"/>
   <p:notesSz cx="6858000" cy="9144000"/>
@@ -3365,7 +3368,7 @@
                 </a:solidFill>
                 <a:latin typeface="Calibri"/>
               </a:rPr>
-              <a:t>Condominio Laguna Norte  ·  Junio 2026</a:t>
+              <a:t>Condominio Laguna Norte  ·  Junio 2026  ·  v1.1</a:t>
             </a:r>
           </a:p>
         </p:txBody>
@@ -3470,7 +3473,7 @@
                 </a:solidFill>
                 <a:latin typeface="Calibri"/>
               </a:rPr>
-              <a:t>Buenas Prácticas</a:t>
+              <a:t>Órdenes de Trabajo</a:t>
             </a:r>
           </a:p>
         </p:txBody>
@@ -3510,22 +3513,81 @@
           </a:p>
         </p:txBody>
       </p:sp>
-      <p:sp>
-        <p:nvSpPr>
-          <p:cNvPr id="5" name="Rounded Rectangle 4"/>
+      <p:pic>
+        <p:nvPicPr>
+          <p:cNvPr id="5" name="Picture 4" descr="03_ot_listado.png"/>
+          <p:cNvPicPr>
+            <a:picLocks noChangeAspect="1"/>
+          </p:cNvPicPr>
+          <p:nvPr/>
+        </p:nvPicPr>
+        <p:blipFill>
+          <a:blip r:embed="rId2"/>
+          <a:stretch>
+            <a:fillRect/>
+          </a:stretch>
+        </p:blipFill>
+        <p:spPr>
+          <a:xfrm>
+            <a:off x="1386687" y="1097280"/>
+            <a:ext cx="9418320" cy="5886450"/>
+          </a:xfrm>
+          <a:prstGeom prst="rect">
+            <a:avLst/>
+          </a:prstGeom>
+        </p:spPr>
+      </p:pic>
+      <p:sp>
+        <p:nvSpPr>
+          <p:cNvPr id="6" name="TextBox 5"/>
+          <p:cNvSpPr txBox="1"/>
+          <p:nvPr/>
+        </p:nvSpPr>
+        <p:spPr>
+          <a:xfrm>
+            <a:off x="914400" y="6035040"/>
+            <a:ext cx="10332720" cy="457200"/>
+          </a:xfrm>
+          <a:prstGeom prst="rect">
+            <a:avLst/>
+          </a:prstGeom>
+          <a:noFill/>
+        </p:spPr>
+        <p:txBody>
+          <a:bodyPr wrap="square" anchor="ctr" lIns="45720" rIns="45720">
+            <a:spAutoFit/>
+          </a:bodyPr>
+          <a:lstStyle/>
+          <a:p>
+            <a:pPr algn="ctr"/>
+            <a:r>
+              <a:rPr sz="1200" b="0">
+                <a:solidFill>
+                  <a:srgbClr val="666666"/>
+                </a:solidFill>
+                <a:latin typeface="Calibri"/>
+              </a:rPr>
+              <a:t>Listado de OT — el admin puede crear, editar, eliminar y aprobar</a:t>
+            </a:r>
+          </a:p>
+        </p:txBody>
+      </p:sp>
+      <p:sp>
+        <p:nvSpPr>
+          <p:cNvPr id="7" name="Rectangle 6"/>
           <p:cNvSpPr/>
           <p:nvPr/>
         </p:nvSpPr>
         <p:spPr>
           <a:xfrm>
-            <a:off x="914400" y="1828800"/>
-            <a:ext cx="10332720" cy="3200400"/>
-          </a:xfrm>
-          <a:prstGeom prst="roundRect">
+            <a:off x="0" y="6583680"/>
+            <a:ext cx="12191695" cy="274320"/>
+          </a:xfrm>
+          <a:prstGeom prst="rect">
             <a:avLst/>
           </a:prstGeom>
           <a:solidFill>
-            <a:srgbClr val="F1F5F9"/>
+            <a:srgbClr val="0F2040"/>
           </a:solidFill>
           <a:ln>
             <a:noFill/>
@@ -3556,58 +3618,14 @@
       </p:sp>
       <p:sp>
         <p:nvSpPr>
-          <p:cNvPr id="6" name="Rectangle 5"/>
-          <p:cNvSpPr/>
-          <p:nvPr/>
-        </p:nvSpPr>
-        <p:spPr>
-          <a:xfrm>
-            <a:off x="914400" y="1828800"/>
-            <a:ext cx="137160" cy="3200400"/>
-          </a:xfrm>
-          <a:prstGeom prst="rect">
-            <a:avLst/>
-          </a:prstGeom>
-          <a:solidFill>
-            <a:srgbClr val="16A34A"/>
-          </a:solidFill>
-          <a:ln>
-            <a:noFill/>
-          </a:ln>
-          <a:effectLst/>
-        </p:spPr>
-        <p:style>
-          <a:lnRef idx="1">
-            <a:schemeClr val="accent1"/>
-          </a:lnRef>
-          <a:fillRef idx="3">
-            <a:schemeClr val="accent1"/>
-          </a:fillRef>
-          <a:effectRef idx="2">
-            <a:schemeClr val="accent1"/>
-          </a:effectRef>
-          <a:fontRef idx="minor">
-            <a:schemeClr val="lt1"/>
-          </a:fontRef>
-        </p:style>
-        <p:txBody>
-          <a:bodyPr rtlCol="0" anchor="ctr"/>
-          <a:lstStyle/>
-          <a:p>
-            <a:pPr algn="ctr"/>
-          </a:p>
-        </p:txBody>
-      </p:sp>
-      <p:sp>
-        <p:nvSpPr>
-          <p:cNvPr id="7" name="TextBox 6"/>
+          <p:cNvPr id="8" name="TextBox 7"/>
           <p:cNvSpPr txBox="1"/>
           <p:nvPr/>
         </p:nvSpPr>
         <p:spPr>
           <a:xfrm>
-            <a:off x="1371600" y="2103120"/>
-            <a:ext cx="1828800" cy="1828800"/>
+            <a:off x="365760" y="6583680"/>
+            <a:ext cx="6400800" cy="274320"/>
           </a:xfrm>
           <a:prstGeom prst="rect">
             <a:avLst/>
@@ -3620,132 +3638,14 @@
           </a:bodyPr>
           <a:lstStyle/>
           <a:p>
-            <a:pPr algn="ctr"/>
-            <a:r>
-              <a:rPr sz="8000" b="0">
-                <a:solidFill>
-                  <a:srgbClr val="16A34A"/>
+            <a:pPr algn="l"/>
+            <a:r>
+              <a:rPr sz="900" b="0">
+                <a:solidFill>
+                  <a:srgbClr val="FFFFFF"/>
                 </a:solidFill>
                 <a:latin typeface="Calibri"/>
               </a:rPr>
-              <a:t>✓</a:t>
-            </a:r>
-          </a:p>
-        </p:txBody>
-      </p:sp>
-      <p:sp>
-        <p:nvSpPr>
-          <p:cNvPr id="8" name="TextBox 7"/>
-          <p:cNvSpPr txBox="1"/>
-          <p:nvPr/>
-        </p:nvSpPr>
-        <p:spPr>
-          <a:xfrm>
-            <a:off x="3474720" y="2103120"/>
-            <a:ext cx="7498079" cy="2743200"/>
-          </a:xfrm>
-          <a:prstGeom prst="rect">
-            <a:avLst/>
-          </a:prstGeom>
-          <a:noFill/>
-        </p:spPr>
-        <p:txBody>
-          <a:bodyPr wrap="square" anchor="ctr" lIns="45720" rIns="45720">
-            <a:spAutoFit/>
-          </a:bodyPr>
-          <a:lstStyle/>
-          <a:p>
-            <a:pPr algn="l"/>
-            <a:r>
-              <a:rPr sz="1800" b="0">
-                <a:solidFill>
-                  <a:srgbClr val="0F2040"/>
-                </a:solidFill>
-                <a:latin typeface="Calibri"/>
-              </a:rPr>
-              <a:t>✓ Revisa el módulo Notificaciones regularmente para estar al día con aprobaciones pendientes
-✓ Usa el módulo Permisos del Sistema como documentación oficial
-✓ No compartas tu contraseña de admin con nadie
-✓ Asigna permisos personalizados solo cuando sea estrictamente necesario
-✓ Revisa la Auditoría periódicamente para detectar uso anómalo</a:t>
-            </a:r>
-          </a:p>
-        </p:txBody>
-      </p:sp>
-      <p:sp>
-        <p:nvSpPr>
-          <p:cNvPr id="9" name="Rectangle 8"/>
-          <p:cNvSpPr/>
-          <p:nvPr/>
-        </p:nvSpPr>
-        <p:spPr>
-          <a:xfrm>
-            <a:off x="0" y="6583680"/>
-            <a:ext cx="12191695" cy="274320"/>
-          </a:xfrm>
-          <a:prstGeom prst="rect">
-            <a:avLst/>
-          </a:prstGeom>
-          <a:solidFill>
-            <a:srgbClr val="0F2040"/>
-          </a:solidFill>
-          <a:ln>
-            <a:noFill/>
-          </a:ln>
-          <a:effectLst/>
-        </p:spPr>
-        <p:style>
-          <a:lnRef idx="1">
-            <a:schemeClr val="accent1"/>
-          </a:lnRef>
-          <a:fillRef idx="3">
-            <a:schemeClr val="accent1"/>
-          </a:fillRef>
-          <a:effectRef idx="2">
-            <a:schemeClr val="accent1"/>
-          </a:effectRef>
-          <a:fontRef idx="minor">
-            <a:schemeClr val="lt1"/>
-          </a:fontRef>
-        </p:style>
-        <p:txBody>
-          <a:bodyPr rtlCol="0" anchor="ctr"/>
-          <a:lstStyle/>
-          <a:p>
-            <a:pPr algn="ctr"/>
-          </a:p>
-        </p:txBody>
-      </p:sp>
-      <p:sp>
-        <p:nvSpPr>
-          <p:cNvPr id="10" name="TextBox 9"/>
-          <p:cNvSpPr txBox="1"/>
-          <p:nvPr/>
-        </p:nvSpPr>
-        <p:spPr>
-          <a:xfrm>
-            <a:off x="365760" y="6583680"/>
-            <a:ext cx="6400800" cy="274320"/>
-          </a:xfrm>
-          <a:prstGeom prst="rect">
-            <a:avLst/>
-          </a:prstGeom>
-          <a:noFill/>
-        </p:spPr>
-        <p:txBody>
-          <a:bodyPr wrap="square" anchor="ctr" lIns="45720" rIns="45720">
-            <a:spAutoFit/>
-          </a:bodyPr>
-          <a:lstStyle/>
-          <a:p>
-            <a:pPr algn="l"/>
-            <a:r>
-              <a:rPr sz="900" b="0">
-                <a:solidFill>
-                  <a:srgbClr val="FFFFFF"/>
-                </a:solidFill>
-                <a:latin typeface="Calibri"/>
-              </a:rPr>
               <a:t>Asesorías Integrales CyJ · Capacitación Administrador</a:t>
             </a:r>
           </a:p>
@@ -3753,7 +3653,7 @@
       </p:sp>
       <p:sp>
         <p:nvSpPr>
-          <p:cNvPr id="11" name="TextBox 10"/>
+          <p:cNvPr id="9" name="TextBox 8"/>
           <p:cNvSpPr txBox="1"/>
           <p:nvPr/>
         </p:nvSpPr>
@@ -3886,7 +3786,7 @@
                 </a:solidFill>
                 <a:latin typeface="Calibri"/>
               </a:rPr>
-              <a:t>Datos de Acceso</a:t>
+              <a:t>Crear Nueva OT</a:t>
             </a:r>
           </a:p>
         </p:txBody>
@@ -3926,16 +3826,40 @@
           </a:p>
         </p:txBody>
       </p:sp>
-      <p:sp>
-        <p:nvSpPr>
-          <p:cNvPr id="5" name="TextBox 4"/>
+      <p:pic>
+        <p:nvPicPr>
+          <p:cNvPr id="5" name="Picture 4" descr="10_ot_crear.png"/>
+          <p:cNvPicPr>
+            <a:picLocks noChangeAspect="1"/>
+          </p:cNvPicPr>
+          <p:nvPr/>
+        </p:nvPicPr>
+        <p:blipFill>
+          <a:blip r:embed="rId2"/>
+          <a:stretch>
+            <a:fillRect/>
+          </a:stretch>
+        </p:blipFill>
+        <p:spPr>
+          <a:xfrm>
+            <a:off x="1386687" y="1097280"/>
+            <a:ext cx="9418320" cy="5886450"/>
+          </a:xfrm>
+          <a:prstGeom prst="rect">
+            <a:avLst/>
+          </a:prstGeom>
+        </p:spPr>
+      </p:pic>
+      <p:sp>
+        <p:nvSpPr>
+          <p:cNvPr id="6" name="TextBox 5"/>
           <p:cNvSpPr txBox="1"/>
           <p:nvPr/>
         </p:nvSpPr>
         <p:spPr>
           <a:xfrm>
-            <a:off x="457200" y="1005840"/>
-            <a:ext cx="11247120" cy="731520"/>
+            <a:off x="914400" y="6035040"/>
+            <a:ext cx="10332720" cy="457200"/>
           </a:xfrm>
           <a:prstGeom prst="rect">
             <a:avLst/>
@@ -3943,183 +3867,20 @@
           <a:noFill/>
         </p:spPr>
         <p:txBody>
-          <a:bodyPr wrap="square" anchor="t" lIns="45720" rIns="45720">
+          <a:bodyPr wrap="square" anchor="ctr" lIns="45720" rIns="45720">
             <a:spAutoFit/>
           </a:bodyPr>
           <a:lstStyle/>
           <a:p>
-            <a:pPr algn="l"/>
-            <a:r>
-              <a:rPr sz="1400" b="0">
+            <a:pPr algn="ctr"/>
+            <a:r>
+              <a:rPr sz="1200" b="0">
                 <a:solidFill>
                   <a:srgbClr val="666666"/>
                 </a:solidFill>
                 <a:latin typeface="Calibri"/>
               </a:rPr>
-              <a:t>URL del sistema y credenciales de tu rol de prueba:</a:t>
-            </a:r>
-          </a:p>
-        </p:txBody>
-      </p:sp>
-      <p:sp>
-        <p:nvSpPr>
-          <p:cNvPr id="6" name="TextBox 5"/>
-          <p:cNvSpPr txBox="1"/>
-          <p:nvPr/>
-        </p:nvSpPr>
-        <p:spPr>
-          <a:xfrm>
-            <a:off x="640080" y="1828800"/>
-            <a:ext cx="10972800" cy="4572000"/>
-          </a:xfrm>
-          <a:prstGeom prst="rect">
-            <a:avLst/>
-          </a:prstGeom>
-          <a:noFill/>
-        </p:spPr>
-        <p:txBody>
-          <a:bodyPr wrap="square">
-            <a:spAutoFit/>
-          </a:bodyPr>
-          <a:lstStyle/>
-          <a:p>
-            <a:pPr algn="l">
-              <a:lnSpc>
-                <a:spcPct val="140000"/>
-              </a:lnSpc>
-              <a:spcAft>
-                <a:spcPts val="800"/>
-              </a:spcAft>
-            </a:pPr>
-            <a:r>
-              <a:rPr sz="1600" b="1">
-                <a:solidFill>
-                  <a:srgbClr val="F59E0B"/>
-                </a:solidFill>
-                <a:latin typeface="Calibri"/>
-              </a:rPr>
-              <a:t>● </a:t>
-            </a:r>
-            <a:r>
-              <a:rPr sz="1600">
-                <a:solidFill>
-                  <a:srgbClr val="0F2040"/>
-                </a:solidFill>
-                <a:latin typeface="Calibri"/>
-              </a:rPr>
-              <a:t>URL: https://condominios-cyj.vercel.app</a:t>
-            </a:r>
-          </a:p>
-          <a:p>
-            <a:pPr algn="l">
-              <a:lnSpc>
-                <a:spcPct val="140000"/>
-              </a:lnSpc>
-              <a:spcAft>
-                <a:spcPts val="800"/>
-              </a:spcAft>
-            </a:pPr>
-            <a:r>
-              <a:rPr sz="1600" b="1">
-                <a:solidFill>
-                  <a:srgbClr val="F59E0B"/>
-                </a:solidFill>
-                <a:latin typeface="Calibri"/>
-              </a:rPr>
-              <a:t>● </a:t>
-            </a:r>
-            <a:r>
-              <a:rPr sz="1600">
-                <a:solidFill>
-                  <a:srgbClr val="0F2040"/>
-                </a:solidFill>
-                <a:latin typeface="Calibri"/>
-              </a:rPr>
-              <a:t>Email: admin@cyj.cl</a:t>
-            </a:r>
-          </a:p>
-          <a:p>
-            <a:pPr algn="l">
-              <a:lnSpc>
-                <a:spcPct val="140000"/>
-              </a:lnSpc>
-              <a:spcAft>
-                <a:spcPts val="800"/>
-              </a:spcAft>
-            </a:pPr>
-            <a:r>
-              <a:rPr sz="1600" b="1">
-                <a:solidFill>
-                  <a:srgbClr val="F59E0B"/>
-                </a:solidFill>
-                <a:latin typeface="Calibri"/>
-              </a:rPr>
-              <a:t>● </a:t>
-            </a:r>
-            <a:r>
-              <a:rPr sz="1600">
-                <a:solidFill>
-                  <a:srgbClr val="0F2040"/>
-                </a:solidFill>
-                <a:latin typeface="Calibri"/>
-              </a:rPr>
-              <a:t>Contraseña: (la que ya tienes configurada)</a:t>
-            </a:r>
-          </a:p>
-          <a:p>
-            <a:pPr algn="l">
-              <a:lnSpc>
-                <a:spcPct val="140000"/>
-              </a:lnSpc>
-              <a:spcAft>
-                <a:spcPts val="800"/>
-              </a:spcAft>
-            </a:pPr>
-            <a:r>
-              <a:rPr sz="1600" b="1">
-                <a:solidFill>
-                  <a:srgbClr val="F59E0B"/>
-                </a:solidFill>
-                <a:latin typeface="Calibri"/>
-              </a:rPr>
-              <a:t>● </a:t>
-            </a:r>
-            <a:r>
-              <a:rPr sz="1600">
-                <a:solidFill>
-                  <a:srgbClr val="0F2040"/>
-                </a:solidFill>
-                <a:latin typeface="Calibri"/>
-              </a:rPr>
-              <a:t>Página de inicio: /sistema (dashboard)</a:t>
-            </a:r>
-          </a:p>
-          <a:p>
-            <a:pPr algn="l">
-              <a:lnSpc>
-                <a:spcPct val="140000"/>
-              </a:lnSpc>
-              <a:spcAft>
-                <a:spcPts val="800"/>
-              </a:spcAft>
-            </a:pPr>
-            <a:r>
-              <a:rPr sz="1600" b="1">
-                <a:solidFill>
-                  <a:srgbClr val="F59E0B"/>
-                </a:solidFill>
-                <a:latin typeface="Calibri"/>
-              </a:rPr>
-              <a:t>● </a:t>
-            </a:r>
-            <a:r>
-              <a:rPr sz="1600">
-                <a:solidFill>
-                  <a:srgbClr val="0F2040"/>
-                </a:solidFill>
-                <a:latin typeface="Calibri"/>
-              </a:rPr>
-              <a:t>Módulo exclusivo: Sistema → Permisos del Sistema</a:t>
+              <a:t>Formulario de creación de OT con asignación de personal</a:t>
             </a:r>
           </a:p>
         </p:txBody>
@@ -4247,6 +4008,1074 @@
 </file>
 
 <file path=ppt/slides/slide12.xml><?xml version="1.0" encoding="utf-8"?>
+<p:sld xmlns:a="http://schemas.openxmlformats.org/drawingml/2006/main" xmlns:p="http://schemas.openxmlformats.org/presentationml/2006/main" xmlns:r="http://schemas.openxmlformats.org/officeDocument/2006/relationships">
+  <p:cSld>
+    <p:bg>
+      <p:bgPr>
+        <a:solidFill>
+          <a:srgbClr val="FFFFFF"/>
+        </a:solidFill>
+        <a:effectLst/>
+      </p:bgPr>
+    </p:bg>
+    <p:spTree>
+      <p:nvGrpSpPr>
+        <p:cNvPr id="1" name=""/>
+        <p:cNvGrpSpPr/>
+        <p:nvPr/>
+      </p:nvGrpSpPr>
+      <p:grpSpPr/>
+      <p:sp>
+        <p:nvSpPr>
+          <p:cNvPr id="2" name="Rectangle 1"/>
+          <p:cNvSpPr/>
+          <p:nvPr/>
+        </p:nvSpPr>
+        <p:spPr>
+          <a:xfrm>
+            <a:off x="0" y="0"/>
+            <a:ext cx="12191695" cy="822960"/>
+          </a:xfrm>
+          <a:prstGeom prst="rect">
+            <a:avLst/>
+          </a:prstGeom>
+          <a:solidFill>
+            <a:srgbClr val="0A1172"/>
+          </a:solidFill>
+          <a:ln>
+            <a:noFill/>
+          </a:ln>
+          <a:effectLst/>
+        </p:spPr>
+        <p:style>
+          <a:lnRef idx="1">
+            <a:schemeClr val="accent1"/>
+          </a:lnRef>
+          <a:fillRef idx="3">
+            <a:schemeClr val="accent1"/>
+          </a:fillRef>
+          <a:effectRef idx="2">
+            <a:schemeClr val="accent1"/>
+          </a:effectRef>
+          <a:fontRef idx="minor">
+            <a:schemeClr val="lt1"/>
+          </a:fontRef>
+        </p:style>
+        <p:txBody>
+          <a:bodyPr rtlCol="0" anchor="ctr"/>
+          <a:lstStyle/>
+          <a:p>
+            <a:pPr algn="ctr"/>
+          </a:p>
+        </p:txBody>
+      </p:sp>
+      <p:sp>
+        <p:nvSpPr>
+          <p:cNvPr id="3" name="TextBox 2"/>
+          <p:cNvSpPr txBox="1"/>
+          <p:nvPr/>
+        </p:nvSpPr>
+        <p:spPr>
+          <a:xfrm>
+            <a:off x="365760" y="137160"/>
+            <a:ext cx="10058400" cy="548640"/>
+          </a:xfrm>
+          <a:prstGeom prst="rect">
+            <a:avLst/>
+          </a:prstGeom>
+          <a:noFill/>
+        </p:spPr>
+        <p:txBody>
+          <a:bodyPr wrap="square" anchor="ctr" lIns="45720" rIns="45720">
+            <a:spAutoFit/>
+          </a:bodyPr>
+          <a:lstStyle/>
+          <a:p>
+            <a:pPr algn="l"/>
+            <a:r>
+              <a:rPr sz="2200" b="1">
+                <a:solidFill>
+                  <a:srgbClr val="FFFFFF"/>
+                </a:solidFill>
+                <a:latin typeface="Calibri"/>
+              </a:rPr>
+              <a:t>Módulo Rondas</a:t>
+            </a:r>
+          </a:p>
+        </p:txBody>
+      </p:sp>
+      <p:sp>
+        <p:nvSpPr>
+          <p:cNvPr id="4" name="TextBox 3"/>
+          <p:cNvSpPr txBox="1"/>
+          <p:nvPr/>
+        </p:nvSpPr>
+        <p:spPr>
+          <a:xfrm>
+            <a:off x="11247120" y="137160"/>
+            <a:ext cx="731520" cy="548640"/>
+          </a:xfrm>
+          <a:prstGeom prst="rect">
+            <a:avLst/>
+          </a:prstGeom>
+          <a:noFill/>
+        </p:spPr>
+        <p:txBody>
+          <a:bodyPr wrap="square" anchor="ctr" lIns="45720" rIns="45720">
+            <a:spAutoFit/>
+          </a:bodyPr>
+          <a:lstStyle/>
+          <a:p>
+            <a:pPr algn="r"/>
+            <a:r>
+              <a:rPr sz="1400" b="0">
+                <a:solidFill>
+                  <a:srgbClr val="F59E0B"/>
+                </a:solidFill>
+                <a:latin typeface="Calibri"/>
+              </a:rPr>
+              <a:t>12</a:t>
+            </a:r>
+          </a:p>
+        </p:txBody>
+      </p:sp>
+      <p:pic>
+        <p:nvPicPr>
+          <p:cNvPr id="5" name="Picture 4" descr="05_rondas.png"/>
+          <p:cNvPicPr>
+            <a:picLocks noChangeAspect="1"/>
+          </p:cNvPicPr>
+          <p:nvPr/>
+        </p:nvPicPr>
+        <p:blipFill>
+          <a:blip r:embed="rId2"/>
+          <a:stretch>
+            <a:fillRect/>
+          </a:stretch>
+        </p:blipFill>
+        <p:spPr>
+          <a:xfrm>
+            <a:off x="1386687" y="1097280"/>
+            <a:ext cx="9418320" cy="5886450"/>
+          </a:xfrm>
+          <a:prstGeom prst="rect">
+            <a:avLst/>
+          </a:prstGeom>
+        </p:spPr>
+      </p:pic>
+      <p:sp>
+        <p:nvSpPr>
+          <p:cNvPr id="6" name="TextBox 5"/>
+          <p:cNvSpPr txBox="1"/>
+          <p:nvPr/>
+        </p:nvSpPr>
+        <p:spPr>
+          <a:xfrm>
+            <a:off x="914400" y="6035040"/>
+            <a:ext cx="10332720" cy="457200"/>
+          </a:xfrm>
+          <a:prstGeom prst="rect">
+            <a:avLst/>
+          </a:prstGeom>
+          <a:noFill/>
+        </p:spPr>
+        <p:txBody>
+          <a:bodyPr wrap="square" anchor="ctr" lIns="45720" rIns="45720">
+            <a:spAutoFit/>
+          </a:bodyPr>
+          <a:lstStyle/>
+          <a:p>
+            <a:pPr algn="ctr"/>
+            <a:r>
+              <a:rPr sz="1200" b="0">
+                <a:solidFill>
+                  <a:srgbClr val="666666"/>
+                </a:solidFill>
+                <a:latin typeface="Calibri"/>
+              </a:rPr>
+              <a:t>Gestión de Rondas — 32 rondas agrupadas por etapa con QR</a:t>
+            </a:r>
+          </a:p>
+        </p:txBody>
+      </p:sp>
+      <p:sp>
+        <p:nvSpPr>
+          <p:cNvPr id="7" name="Rectangle 6"/>
+          <p:cNvSpPr/>
+          <p:nvPr/>
+        </p:nvSpPr>
+        <p:spPr>
+          <a:xfrm>
+            <a:off x="0" y="6583680"/>
+            <a:ext cx="12191695" cy="274320"/>
+          </a:xfrm>
+          <a:prstGeom prst="rect">
+            <a:avLst/>
+          </a:prstGeom>
+          <a:solidFill>
+            <a:srgbClr val="0F2040"/>
+          </a:solidFill>
+          <a:ln>
+            <a:noFill/>
+          </a:ln>
+          <a:effectLst/>
+        </p:spPr>
+        <p:style>
+          <a:lnRef idx="1">
+            <a:schemeClr val="accent1"/>
+          </a:lnRef>
+          <a:fillRef idx="3">
+            <a:schemeClr val="accent1"/>
+          </a:fillRef>
+          <a:effectRef idx="2">
+            <a:schemeClr val="accent1"/>
+          </a:effectRef>
+          <a:fontRef idx="minor">
+            <a:schemeClr val="lt1"/>
+          </a:fontRef>
+        </p:style>
+        <p:txBody>
+          <a:bodyPr rtlCol="0" anchor="ctr"/>
+          <a:lstStyle/>
+          <a:p>
+            <a:pPr algn="ctr"/>
+          </a:p>
+        </p:txBody>
+      </p:sp>
+      <p:sp>
+        <p:nvSpPr>
+          <p:cNvPr id="8" name="TextBox 7"/>
+          <p:cNvSpPr txBox="1"/>
+          <p:nvPr/>
+        </p:nvSpPr>
+        <p:spPr>
+          <a:xfrm>
+            <a:off x="365760" y="6583680"/>
+            <a:ext cx="6400800" cy="274320"/>
+          </a:xfrm>
+          <a:prstGeom prst="rect">
+            <a:avLst/>
+          </a:prstGeom>
+          <a:noFill/>
+        </p:spPr>
+        <p:txBody>
+          <a:bodyPr wrap="square" anchor="ctr" lIns="45720" rIns="45720">
+            <a:spAutoFit/>
+          </a:bodyPr>
+          <a:lstStyle/>
+          <a:p>
+            <a:pPr algn="l"/>
+            <a:r>
+              <a:rPr sz="900" b="0">
+                <a:solidFill>
+                  <a:srgbClr val="FFFFFF"/>
+                </a:solidFill>
+                <a:latin typeface="Calibri"/>
+              </a:rPr>
+              <a:t>Asesorías Integrales CyJ · Capacitación Administrador</a:t>
+            </a:r>
+          </a:p>
+        </p:txBody>
+      </p:sp>
+      <p:sp>
+        <p:nvSpPr>
+          <p:cNvPr id="9" name="TextBox 8"/>
+          <p:cNvSpPr txBox="1"/>
+          <p:nvPr/>
+        </p:nvSpPr>
+        <p:spPr>
+          <a:xfrm>
+            <a:off x="7315200" y="6583680"/>
+            <a:ext cx="4572000" cy="274320"/>
+          </a:xfrm>
+          <a:prstGeom prst="rect">
+            <a:avLst/>
+          </a:prstGeom>
+          <a:noFill/>
+        </p:spPr>
+        <p:txBody>
+          <a:bodyPr wrap="square" anchor="ctr" lIns="45720" rIns="45720">
+            <a:spAutoFit/>
+          </a:bodyPr>
+          <a:lstStyle/>
+          <a:p>
+            <a:pPr algn="r"/>
+            <a:r>
+              <a:rPr sz="900" b="0">
+                <a:solidFill>
+                  <a:srgbClr val="F59E0B"/>
+                </a:solidFill>
+                <a:latin typeface="Calibri"/>
+              </a:rPr>
+              <a:t>https://condominios-cyj.vercel.app</a:t>
+            </a:r>
+          </a:p>
+        </p:txBody>
+      </p:sp>
+    </p:spTree>
+  </p:cSld>
+  <p:clrMapOvr>
+    <a:masterClrMapping/>
+  </p:clrMapOvr>
+</p:sld>
+</file>
+
+<file path=ppt/slides/slide13.xml><?xml version="1.0" encoding="utf-8"?>
+<p:sld xmlns:a="http://schemas.openxmlformats.org/drawingml/2006/main" xmlns:p="http://schemas.openxmlformats.org/presentationml/2006/main" xmlns:r="http://schemas.openxmlformats.org/officeDocument/2006/relationships">
+  <p:cSld>
+    <p:bg>
+      <p:bgPr>
+        <a:solidFill>
+          <a:srgbClr val="FFFFFF"/>
+        </a:solidFill>
+        <a:effectLst/>
+      </p:bgPr>
+    </p:bg>
+    <p:spTree>
+      <p:nvGrpSpPr>
+        <p:cNvPr id="1" name=""/>
+        <p:cNvGrpSpPr/>
+        <p:nvPr/>
+      </p:nvGrpSpPr>
+      <p:grpSpPr/>
+      <p:sp>
+        <p:nvSpPr>
+          <p:cNvPr id="2" name="Rectangle 1"/>
+          <p:cNvSpPr/>
+          <p:nvPr/>
+        </p:nvSpPr>
+        <p:spPr>
+          <a:xfrm>
+            <a:off x="0" y="0"/>
+            <a:ext cx="12191695" cy="822960"/>
+          </a:xfrm>
+          <a:prstGeom prst="rect">
+            <a:avLst/>
+          </a:prstGeom>
+          <a:solidFill>
+            <a:srgbClr val="0A1172"/>
+          </a:solidFill>
+          <a:ln>
+            <a:noFill/>
+          </a:ln>
+          <a:effectLst/>
+        </p:spPr>
+        <p:style>
+          <a:lnRef idx="1">
+            <a:schemeClr val="accent1"/>
+          </a:lnRef>
+          <a:fillRef idx="3">
+            <a:schemeClr val="accent1"/>
+          </a:fillRef>
+          <a:effectRef idx="2">
+            <a:schemeClr val="accent1"/>
+          </a:effectRef>
+          <a:fontRef idx="minor">
+            <a:schemeClr val="lt1"/>
+          </a:fontRef>
+        </p:style>
+        <p:txBody>
+          <a:bodyPr rtlCol="0" anchor="ctr"/>
+          <a:lstStyle/>
+          <a:p>
+            <a:pPr algn="ctr"/>
+          </a:p>
+        </p:txBody>
+      </p:sp>
+      <p:sp>
+        <p:nvSpPr>
+          <p:cNvPr id="3" name="TextBox 2"/>
+          <p:cNvSpPr txBox="1"/>
+          <p:nvPr/>
+        </p:nvSpPr>
+        <p:spPr>
+          <a:xfrm>
+            <a:off x="365760" y="137160"/>
+            <a:ext cx="10058400" cy="548640"/>
+          </a:xfrm>
+          <a:prstGeom prst="rect">
+            <a:avLst/>
+          </a:prstGeom>
+          <a:noFill/>
+        </p:spPr>
+        <p:txBody>
+          <a:bodyPr wrap="square" anchor="ctr" lIns="45720" rIns="45720">
+            <a:spAutoFit/>
+          </a:bodyPr>
+          <a:lstStyle/>
+          <a:p>
+            <a:pPr algn="l"/>
+            <a:r>
+              <a:rPr sz="2200" b="1">
+                <a:solidFill>
+                  <a:srgbClr val="FFFFFF"/>
+                </a:solidFill>
+                <a:latin typeface="Calibri"/>
+              </a:rPr>
+              <a:t>Manuales y Capacitaciones</a:t>
+            </a:r>
+          </a:p>
+        </p:txBody>
+      </p:sp>
+      <p:sp>
+        <p:nvSpPr>
+          <p:cNvPr id="4" name="TextBox 3"/>
+          <p:cNvSpPr txBox="1"/>
+          <p:nvPr/>
+        </p:nvSpPr>
+        <p:spPr>
+          <a:xfrm>
+            <a:off x="11247120" y="137160"/>
+            <a:ext cx="731520" cy="548640"/>
+          </a:xfrm>
+          <a:prstGeom prst="rect">
+            <a:avLst/>
+          </a:prstGeom>
+          <a:noFill/>
+        </p:spPr>
+        <p:txBody>
+          <a:bodyPr wrap="square" anchor="ctr" lIns="45720" rIns="45720">
+            <a:spAutoFit/>
+          </a:bodyPr>
+          <a:lstStyle/>
+          <a:p>
+            <a:pPr algn="r"/>
+            <a:r>
+              <a:rPr sz="1400" b="0">
+                <a:solidFill>
+                  <a:srgbClr val="F59E0B"/>
+                </a:solidFill>
+                <a:latin typeface="Calibri"/>
+              </a:rPr>
+              <a:t>13</a:t>
+            </a:r>
+          </a:p>
+        </p:txBody>
+      </p:sp>
+      <p:pic>
+        <p:nvPicPr>
+          <p:cNvPr id="5" name="Picture 4" descr="09_manuales.png"/>
+          <p:cNvPicPr>
+            <a:picLocks noChangeAspect="1"/>
+          </p:cNvPicPr>
+          <p:nvPr/>
+        </p:nvPicPr>
+        <p:blipFill>
+          <a:blip r:embed="rId2"/>
+          <a:stretch>
+            <a:fillRect/>
+          </a:stretch>
+        </p:blipFill>
+        <p:spPr>
+          <a:xfrm>
+            <a:off x="1386687" y="1097280"/>
+            <a:ext cx="9418320" cy="5886450"/>
+          </a:xfrm>
+          <a:prstGeom prst="rect">
+            <a:avLst/>
+          </a:prstGeom>
+        </p:spPr>
+      </p:pic>
+      <p:sp>
+        <p:nvSpPr>
+          <p:cNvPr id="6" name="TextBox 5"/>
+          <p:cNvSpPr txBox="1"/>
+          <p:nvPr/>
+        </p:nvSpPr>
+        <p:spPr>
+          <a:xfrm>
+            <a:off x="914400" y="6035040"/>
+            <a:ext cx="10332720" cy="457200"/>
+          </a:xfrm>
+          <a:prstGeom prst="rect">
+            <a:avLst/>
+          </a:prstGeom>
+          <a:noFill/>
+        </p:spPr>
+        <p:txBody>
+          <a:bodyPr wrap="square" anchor="ctr" lIns="45720" rIns="45720">
+            <a:spAutoFit/>
+          </a:bodyPr>
+          <a:lstStyle/>
+          <a:p>
+            <a:pPr algn="ctr"/>
+            <a:r>
+              <a:rPr sz="1200" b="0">
+                <a:solidFill>
+                  <a:srgbClr val="666666"/>
+                </a:solidFill>
+                <a:latin typeface="Calibri"/>
+              </a:rPr>
+              <a:t>Módulo de descarga de manuales — visible para todos los roles</a:t>
+            </a:r>
+          </a:p>
+        </p:txBody>
+      </p:sp>
+      <p:sp>
+        <p:nvSpPr>
+          <p:cNvPr id="7" name="Rectangle 6"/>
+          <p:cNvSpPr/>
+          <p:nvPr/>
+        </p:nvSpPr>
+        <p:spPr>
+          <a:xfrm>
+            <a:off x="0" y="6583680"/>
+            <a:ext cx="12191695" cy="274320"/>
+          </a:xfrm>
+          <a:prstGeom prst="rect">
+            <a:avLst/>
+          </a:prstGeom>
+          <a:solidFill>
+            <a:srgbClr val="0F2040"/>
+          </a:solidFill>
+          <a:ln>
+            <a:noFill/>
+          </a:ln>
+          <a:effectLst/>
+        </p:spPr>
+        <p:style>
+          <a:lnRef idx="1">
+            <a:schemeClr val="accent1"/>
+          </a:lnRef>
+          <a:fillRef idx="3">
+            <a:schemeClr val="accent1"/>
+          </a:fillRef>
+          <a:effectRef idx="2">
+            <a:schemeClr val="accent1"/>
+          </a:effectRef>
+          <a:fontRef idx="minor">
+            <a:schemeClr val="lt1"/>
+          </a:fontRef>
+        </p:style>
+        <p:txBody>
+          <a:bodyPr rtlCol="0" anchor="ctr"/>
+          <a:lstStyle/>
+          <a:p>
+            <a:pPr algn="ctr"/>
+          </a:p>
+        </p:txBody>
+      </p:sp>
+      <p:sp>
+        <p:nvSpPr>
+          <p:cNvPr id="8" name="TextBox 7"/>
+          <p:cNvSpPr txBox="1"/>
+          <p:nvPr/>
+        </p:nvSpPr>
+        <p:spPr>
+          <a:xfrm>
+            <a:off x="365760" y="6583680"/>
+            <a:ext cx="6400800" cy="274320"/>
+          </a:xfrm>
+          <a:prstGeom prst="rect">
+            <a:avLst/>
+          </a:prstGeom>
+          <a:noFill/>
+        </p:spPr>
+        <p:txBody>
+          <a:bodyPr wrap="square" anchor="ctr" lIns="45720" rIns="45720">
+            <a:spAutoFit/>
+          </a:bodyPr>
+          <a:lstStyle/>
+          <a:p>
+            <a:pPr algn="l"/>
+            <a:r>
+              <a:rPr sz="900" b="0">
+                <a:solidFill>
+                  <a:srgbClr val="FFFFFF"/>
+                </a:solidFill>
+                <a:latin typeface="Calibri"/>
+              </a:rPr>
+              <a:t>Asesorías Integrales CyJ · Capacitación Administrador</a:t>
+            </a:r>
+          </a:p>
+        </p:txBody>
+      </p:sp>
+      <p:sp>
+        <p:nvSpPr>
+          <p:cNvPr id="9" name="TextBox 8"/>
+          <p:cNvSpPr txBox="1"/>
+          <p:nvPr/>
+        </p:nvSpPr>
+        <p:spPr>
+          <a:xfrm>
+            <a:off x="7315200" y="6583680"/>
+            <a:ext cx="4572000" cy="274320"/>
+          </a:xfrm>
+          <a:prstGeom prst="rect">
+            <a:avLst/>
+          </a:prstGeom>
+          <a:noFill/>
+        </p:spPr>
+        <p:txBody>
+          <a:bodyPr wrap="square" anchor="ctr" lIns="45720" rIns="45720">
+            <a:spAutoFit/>
+          </a:bodyPr>
+          <a:lstStyle/>
+          <a:p>
+            <a:pPr algn="r"/>
+            <a:r>
+              <a:rPr sz="900" b="0">
+                <a:solidFill>
+                  <a:srgbClr val="F59E0B"/>
+                </a:solidFill>
+                <a:latin typeface="Calibri"/>
+              </a:rPr>
+              <a:t>https://condominios-cyj.vercel.app</a:t>
+            </a:r>
+          </a:p>
+        </p:txBody>
+      </p:sp>
+    </p:spTree>
+  </p:cSld>
+  <p:clrMapOvr>
+    <a:masterClrMapping/>
+  </p:clrMapOvr>
+</p:sld>
+</file>
+
+<file path=ppt/slides/slide14.xml><?xml version="1.0" encoding="utf-8"?>
+<p:sld xmlns:a="http://schemas.openxmlformats.org/drawingml/2006/main" xmlns:p="http://schemas.openxmlformats.org/presentationml/2006/main" xmlns:r="http://schemas.openxmlformats.org/officeDocument/2006/relationships">
+  <p:cSld>
+    <p:bg>
+      <p:bgPr>
+        <a:solidFill>
+          <a:srgbClr val="FFFFFF"/>
+        </a:solidFill>
+        <a:effectLst/>
+      </p:bgPr>
+    </p:bg>
+    <p:spTree>
+      <p:nvGrpSpPr>
+        <p:cNvPr id="1" name=""/>
+        <p:cNvGrpSpPr/>
+        <p:nvPr/>
+      </p:nvGrpSpPr>
+      <p:grpSpPr/>
+      <p:sp>
+        <p:nvSpPr>
+          <p:cNvPr id="2" name="Rectangle 1"/>
+          <p:cNvSpPr/>
+          <p:nvPr/>
+        </p:nvSpPr>
+        <p:spPr>
+          <a:xfrm>
+            <a:off x="0" y="0"/>
+            <a:ext cx="12191695" cy="822960"/>
+          </a:xfrm>
+          <a:prstGeom prst="rect">
+            <a:avLst/>
+          </a:prstGeom>
+          <a:solidFill>
+            <a:srgbClr val="0A1172"/>
+          </a:solidFill>
+          <a:ln>
+            <a:noFill/>
+          </a:ln>
+          <a:effectLst/>
+        </p:spPr>
+        <p:style>
+          <a:lnRef idx="1">
+            <a:schemeClr val="accent1"/>
+          </a:lnRef>
+          <a:fillRef idx="3">
+            <a:schemeClr val="accent1"/>
+          </a:fillRef>
+          <a:effectRef idx="2">
+            <a:schemeClr val="accent1"/>
+          </a:effectRef>
+          <a:fontRef idx="minor">
+            <a:schemeClr val="lt1"/>
+          </a:fontRef>
+        </p:style>
+        <p:txBody>
+          <a:bodyPr rtlCol="0" anchor="ctr"/>
+          <a:lstStyle/>
+          <a:p>
+            <a:pPr algn="ctr"/>
+          </a:p>
+        </p:txBody>
+      </p:sp>
+      <p:sp>
+        <p:nvSpPr>
+          <p:cNvPr id="3" name="TextBox 2"/>
+          <p:cNvSpPr txBox="1"/>
+          <p:nvPr/>
+        </p:nvSpPr>
+        <p:spPr>
+          <a:xfrm>
+            <a:off x="365760" y="137160"/>
+            <a:ext cx="10058400" cy="548640"/>
+          </a:xfrm>
+          <a:prstGeom prst="rect">
+            <a:avLst/>
+          </a:prstGeom>
+          <a:noFill/>
+        </p:spPr>
+        <p:txBody>
+          <a:bodyPr wrap="square" anchor="ctr" lIns="45720" rIns="45720">
+            <a:spAutoFit/>
+          </a:bodyPr>
+          <a:lstStyle/>
+          <a:p>
+            <a:pPr algn="l"/>
+            <a:r>
+              <a:rPr sz="2200" b="1">
+                <a:solidFill>
+                  <a:srgbClr val="FFFFFF"/>
+                </a:solidFill>
+                <a:latin typeface="Calibri"/>
+              </a:rPr>
+              <a:t>Datos de Acceso</a:t>
+            </a:r>
+          </a:p>
+        </p:txBody>
+      </p:sp>
+      <p:sp>
+        <p:nvSpPr>
+          <p:cNvPr id="4" name="TextBox 3"/>
+          <p:cNvSpPr txBox="1"/>
+          <p:nvPr/>
+        </p:nvSpPr>
+        <p:spPr>
+          <a:xfrm>
+            <a:off x="11247120" y="137160"/>
+            <a:ext cx="731520" cy="548640"/>
+          </a:xfrm>
+          <a:prstGeom prst="rect">
+            <a:avLst/>
+          </a:prstGeom>
+          <a:noFill/>
+        </p:spPr>
+        <p:txBody>
+          <a:bodyPr wrap="square" anchor="ctr" lIns="45720" rIns="45720">
+            <a:spAutoFit/>
+          </a:bodyPr>
+          <a:lstStyle/>
+          <a:p>
+            <a:pPr algn="r"/>
+            <a:r>
+              <a:rPr sz="1400" b="0">
+                <a:solidFill>
+                  <a:srgbClr val="F59E0B"/>
+                </a:solidFill>
+                <a:latin typeface="Calibri"/>
+              </a:rPr>
+              <a:t>14</a:t>
+            </a:r>
+          </a:p>
+        </p:txBody>
+      </p:sp>
+      <p:sp>
+        <p:nvSpPr>
+          <p:cNvPr id="5" name="TextBox 4"/>
+          <p:cNvSpPr txBox="1"/>
+          <p:nvPr/>
+        </p:nvSpPr>
+        <p:spPr>
+          <a:xfrm>
+            <a:off x="457200" y="1005840"/>
+            <a:ext cx="11247120" cy="731520"/>
+          </a:xfrm>
+          <a:prstGeom prst="rect">
+            <a:avLst/>
+          </a:prstGeom>
+          <a:noFill/>
+        </p:spPr>
+        <p:txBody>
+          <a:bodyPr wrap="square" anchor="t" lIns="45720" rIns="45720">
+            <a:spAutoFit/>
+          </a:bodyPr>
+          <a:lstStyle/>
+          <a:p>
+            <a:pPr algn="l"/>
+            <a:r>
+              <a:rPr sz="1400" b="0">
+                <a:solidFill>
+                  <a:srgbClr val="666666"/>
+                </a:solidFill>
+                <a:latin typeface="Calibri"/>
+              </a:rPr>
+              <a:t>Credenciales del administrador:</a:t>
+            </a:r>
+          </a:p>
+        </p:txBody>
+      </p:sp>
+      <p:sp>
+        <p:nvSpPr>
+          <p:cNvPr id="6" name="TextBox 5"/>
+          <p:cNvSpPr txBox="1"/>
+          <p:nvPr/>
+        </p:nvSpPr>
+        <p:spPr>
+          <a:xfrm>
+            <a:off x="640080" y="1828800"/>
+            <a:ext cx="10972800" cy="4572000"/>
+          </a:xfrm>
+          <a:prstGeom prst="rect">
+            <a:avLst/>
+          </a:prstGeom>
+          <a:noFill/>
+        </p:spPr>
+        <p:txBody>
+          <a:bodyPr wrap="square">
+            <a:spAutoFit/>
+          </a:bodyPr>
+          <a:lstStyle/>
+          <a:p>
+            <a:pPr algn="l">
+              <a:lnSpc>
+                <a:spcPct val="140000"/>
+              </a:lnSpc>
+              <a:spcAft>
+                <a:spcPts val="800"/>
+              </a:spcAft>
+            </a:pPr>
+            <a:r>
+              <a:rPr sz="1600" b="1">
+                <a:solidFill>
+                  <a:srgbClr val="F59E0B"/>
+                </a:solidFill>
+              </a:rPr>
+              <a:t>● </a:t>
+            </a:r>
+            <a:r>
+              <a:rPr sz="1600">
+                <a:solidFill>
+                  <a:srgbClr val="0F2040"/>
+                </a:solidFill>
+              </a:rPr>
+              <a:t>URL: https://condominios-cyj.vercel.app</a:t>
+            </a:r>
+          </a:p>
+          <a:p>
+            <a:pPr algn="l">
+              <a:lnSpc>
+                <a:spcPct val="140000"/>
+              </a:lnSpc>
+              <a:spcAft>
+                <a:spcPts val="800"/>
+              </a:spcAft>
+            </a:pPr>
+            <a:r>
+              <a:rPr sz="1600" b="1">
+                <a:solidFill>
+                  <a:srgbClr val="F59E0B"/>
+                </a:solidFill>
+              </a:rPr>
+              <a:t>● </a:t>
+            </a:r>
+            <a:r>
+              <a:rPr sz="1600">
+                <a:solidFill>
+                  <a:srgbClr val="0F2040"/>
+                </a:solidFill>
+              </a:rPr>
+              <a:t>Email: admin@cyj.cl</a:t>
+            </a:r>
+          </a:p>
+          <a:p>
+            <a:pPr algn="l">
+              <a:lnSpc>
+                <a:spcPct val="140000"/>
+              </a:lnSpc>
+              <a:spcAft>
+                <a:spcPts val="800"/>
+              </a:spcAft>
+            </a:pPr>
+            <a:r>
+              <a:rPr sz="1600" b="1">
+                <a:solidFill>
+                  <a:srgbClr val="F59E0B"/>
+                </a:solidFill>
+              </a:rPr>
+              <a:t>● </a:t>
+            </a:r>
+            <a:r>
+              <a:rPr sz="1600">
+                <a:solidFill>
+                  <a:srgbClr val="0F2040"/>
+                </a:solidFill>
+              </a:rPr>
+              <a:t>Contraseña: (la que ya tienes configurada)</a:t>
+            </a:r>
+          </a:p>
+          <a:p>
+            <a:pPr algn="l">
+              <a:lnSpc>
+                <a:spcPct val="140000"/>
+              </a:lnSpc>
+              <a:spcAft>
+                <a:spcPts val="800"/>
+              </a:spcAft>
+            </a:pPr>
+            <a:r>
+              <a:rPr sz="1600" b="1">
+                <a:solidFill>
+                  <a:srgbClr val="F59E0B"/>
+                </a:solidFill>
+              </a:rPr>
+              <a:t>● </a:t>
+            </a:r>
+            <a:r>
+              <a:rPr sz="1600">
+                <a:solidFill>
+                  <a:srgbClr val="0F2040"/>
+                </a:solidFill>
+              </a:rPr>
+              <a:t>Página de inicio: /sistema (dashboard)</a:t>
+            </a:r>
+          </a:p>
+          <a:p>
+            <a:pPr algn="l">
+              <a:lnSpc>
+                <a:spcPct val="140000"/>
+              </a:lnSpc>
+              <a:spcAft>
+                <a:spcPts val="800"/>
+              </a:spcAft>
+            </a:pPr>
+            <a:r>
+              <a:rPr sz="1600" b="1">
+                <a:solidFill>
+                  <a:srgbClr val="F59E0B"/>
+                </a:solidFill>
+              </a:rPr>
+              <a:t>● </a:t>
+            </a:r>
+            <a:r>
+              <a:rPr sz="1600">
+                <a:solidFill>
+                  <a:srgbClr val="0F2040"/>
+                </a:solidFill>
+              </a:rPr>
+              <a:t>Módulo exclusivo: Sistema → Permisos del Sistema</a:t>
+            </a:r>
+          </a:p>
+        </p:txBody>
+      </p:sp>
+      <p:sp>
+        <p:nvSpPr>
+          <p:cNvPr id="7" name="Rectangle 6"/>
+          <p:cNvSpPr/>
+          <p:nvPr/>
+        </p:nvSpPr>
+        <p:spPr>
+          <a:xfrm>
+            <a:off x="0" y="6583680"/>
+            <a:ext cx="12191695" cy="274320"/>
+          </a:xfrm>
+          <a:prstGeom prst="rect">
+            <a:avLst/>
+          </a:prstGeom>
+          <a:solidFill>
+            <a:srgbClr val="0F2040"/>
+          </a:solidFill>
+          <a:ln>
+            <a:noFill/>
+          </a:ln>
+          <a:effectLst/>
+        </p:spPr>
+        <p:style>
+          <a:lnRef idx="1">
+            <a:schemeClr val="accent1"/>
+          </a:lnRef>
+          <a:fillRef idx="3">
+            <a:schemeClr val="accent1"/>
+          </a:fillRef>
+          <a:effectRef idx="2">
+            <a:schemeClr val="accent1"/>
+          </a:effectRef>
+          <a:fontRef idx="minor">
+            <a:schemeClr val="lt1"/>
+          </a:fontRef>
+        </p:style>
+        <p:txBody>
+          <a:bodyPr rtlCol="0" anchor="ctr"/>
+          <a:lstStyle/>
+          <a:p>
+            <a:pPr algn="ctr"/>
+          </a:p>
+        </p:txBody>
+      </p:sp>
+      <p:sp>
+        <p:nvSpPr>
+          <p:cNvPr id="8" name="TextBox 7"/>
+          <p:cNvSpPr txBox="1"/>
+          <p:nvPr/>
+        </p:nvSpPr>
+        <p:spPr>
+          <a:xfrm>
+            <a:off x="365760" y="6583680"/>
+            <a:ext cx="6400800" cy="274320"/>
+          </a:xfrm>
+          <a:prstGeom prst="rect">
+            <a:avLst/>
+          </a:prstGeom>
+          <a:noFill/>
+        </p:spPr>
+        <p:txBody>
+          <a:bodyPr wrap="square" anchor="ctr" lIns="45720" rIns="45720">
+            <a:spAutoFit/>
+          </a:bodyPr>
+          <a:lstStyle/>
+          <a:p>
+            <a:pPr algn="l"/>
+            <a:r>
+              <a:rPr sz="900" b="0">
+                <a:solidFill>
+                  <a:srgbClr val="FFFFFF"/>
+                </a:solidFill>
+                <a:latin typeface="Calibri"/>
+              </a:rPr>
+              <a:t>Asesorías Integrales CyJ · Capacitación Administrador</a:t>
+            </a:r>
+          </a:p>
+        </p:txBody>
+      </p:sp>
+      <p:sp>
+        <p:nvSpPr>
+          <p:cNvPr id="9" name="TextBox 8"/>
+          <p:cNvSpPr txBox="1"/>
+          <p:nvPr/>
+        </p:nvSpPr>
+        <p:spPr>
+          <a:xfrm>
+            <a:off x="7315200" y="6583680"/>
+            <a:ext cx="4572000" cy="274320"/>
+          </a:xfrm>
+          <a:prstGeom prst="rect">
+            <a:avLst/>
+          </a:prstGeom>
+          <a:noFill/>
+        </p:spPr>
+        <p:txBody>
+          <a:bodyPr wrap="square" anchor="ctr" lIns="45720" rIns="45720">
+            <a:spAutoFit/>
+          </a:bodyPr>
+          <a:lstStyle/>
+          <a:p>
+            <a:pPr algn="r"/>
+            <a:r>
+              <a:rPr sz="900" b="0">
+                <a:solidFill>
+                  <a:srgbClr val="F59E0B"/>
+                </a:solidFill>
+                <a:latin typeface="Calibri"/>
+              </a:rPr>
+              <a:t>https://condominios-cyj.vercel.app</a:t>
+            </a:r>
+          </a:p>
+        </p:txBody>
+      </p:sp>
+    </p:spTree>
+  </p:cSld>
+  <p:clrMapOvr>
+    <a:masterClrMapping/>
+  </p:clrMapOvr>
+</p:sld>
+</file>
+
+<file path=ppt/slides/slide15.xml><?xml version="1.0" encoding="utf-8"?>
 <p:sld xmlns:a="http://schemas.openxmlformats.org/drawingml/2006/main" xmlns:p="http://schemas.openxmlformats.org/presentationml/2006/main" xmlns:r="http://schemas.openxmlformats.org/officeDocument/2006/relationships">
   <p:cSld>
     <p:bg>
@@ -4618,7 +5447,7 @@
                 </a:solidFill>
                 <a:latin typeface="Calibri"/>
               </a:rPr>
-              <a:t>Como Administrador tienes control completo del sistema. Eres el responsable de la configuración, usuarios y permisos.</a:t>
+              <a:t>Como Administrador tienes control completo del sistema.</a:t>
             </a:r>
           </a:p>
         </p:txBody>
@@ -4658,7 +5487,6 @@
                 <a:solidFill>
                   <a:srgbClr val="F59E0B"/>
                 </a:solidFill>
-                <a:latin typeface="Calibri"/>
               </a:rPr>
               <a:t>● </a:t>
             </a:r>
@@ -4667,7 +5495,6 @@
                 <a:solidFill>
                   <a:srgbClr val="0F2040"/>
                 </a:solidFill>
-                <a:latin typeface="Calibri"/>
               </a:rPr>
               <a:t>Gestionar usuarios: crear, editar, eliminar y restablecer contraseñas</a:t>
             </a:r>
@@ -4686,7 +5513,6 @@
                 <a:solidFill>
                   <a:srgbClr val="F59E0B"/>
                 </a:solidFill>
-                <a:latin typeface="Calibri"/>
               </a:rPr>
               <a:t>● </a:t>
             </a:r>
@@ -4695,7 +5521,6 @@
                 <a:solidFill>
                   <a:srgbClr val="0F2040"/>
                 </a:solidFill>
-                <a:latin typeface="Calibri"/>
               </a:rPr>
               <a:t>Configurar permisos del sistema (módulo exclusivo)</a:t>
             </a:r>
@@ -4714,7 +5539,6 @@
                 <a:solidFill>
                   <a:srgbClr val="F59E0B"/>
                 </a:solidFill>
-                <a:latin typeface="Calibri"/>
               </a:rPr>
               <a:t>● </a:t>
             </a:r>
@@ -4723,7 +5547,6 @@
                 <a:solidFill>
                   <a:srgbClr val="0F2040"/>
                 </a:solidFill>
-                <a:latin typeface="Calibri"/>
               </a:rPr>
               <a:t>Aprobar Solicitudes de Compra en la 2da etapa (gestionar compra)</a:t>
             </a:r>
@@ -4742,7 +5565,6 @@
                 <a:solidFill>
                   <a:srgbClr val="F59E0B"/>
                 </a:solidFill>
-                <a:latin typeface="Calibri"/>
               </a:rPr>
               <a:t>● </a:t>
             </a:r>
@@ -4751,7 +5573,6 @@
                 <a:solidFill>
                   <a:srgbClr val="0F2040"/>
                 </a:solidFill>
-                <a:latin typeface="Calibri"/>
               </a:rPr>
               <a:t>Aprobar/rechazar Órdenes de Trabajo completadas</a:t>
             </a:r>
@@ -4770,7 +5591,6 @@
                 <a:solidFill>
                   <a:srgbClr val="F59E0B"/>
                 </a:solidFill>
-                <a:latin typeface="Calibri"/>
               </a:rPr>
               <a:t>● </a:t>
             </a:r>
@@ -4779,7 +5599,6 @@
                 <a:solidFill>
                   <a:srgbClr val="0F2040"/>
                 </a:solidFill>
-                <a:latin typeface="Calibri"/>
               </a:rPr>
               <a:t>Gestionar Respaldos de la base de datos</a:t>
             </a:r>
@@ -4798,7 +5617,6 @@
                 <a:solidFill>
                   <a:srgbClr val="F59E0B"/>
                 </a:solidFill>
-                <a:latin typeface="Calibri"/>
               </a:rPr>
               <a:t>● </a:t>
             </a:r>
@@ -4807,7 +5625,6 @@
                 <a:solidFill>
                   <a:srgbClr val="0F2040"/>
                 </a:solidFill>
-                <a:latin typeface="Calibri"/>
               </a:rPr>
               <a:t>Ver Auditoría completa (logs de todas las acciones)</a:t>
             </a:r>
@@ -4826,7 +5643,6 @@
                 <a:solidFill>
                   <a:srgbClr val="F59E0B"/>
                 </a:solidFill>
-                <a:latin typeface="Calibri"/>
               </a:rPr>
               <a:t>● </a:t>
             </a:r>
@@ -4835,37 +5651,8 @@
                 <a:solidFill>
                   <a:srgbClr val="0F2040"/>
                 </a:solidFill>
-                <a:latin typeface="Calibri"/>
-              </a:rPr>
-              <a:t>Acceso a Cumplimiento Legal y Respaldos</a:t>
-            </a:r>
-          </a:p>
-          <a:p>
-            <a:pPr algn="l">
-              <a:lnSpc>
-                <a:spcPct val="140000"/>
-              </a:lnSpc>
-              <a:spcAft>
-                <a:spcPts val="800"/>
-              </a:spcAft>
-            </a:pPr>
-            <a:r>
-              <a:rPr sz="1600" b="1">
-                <a:solidFill>
-                  <a:srgbClr val="F59E0B"/>
-                </a:solidFill>
-                <a:latin typeface="Calibri"/>
-              </a:rPr>
-              <a:t>● </a:t>
-            </a:r>
-            <a:r>
-              <a:rPr sz="1600">
-                <a:solidFill>
-                  <a:srgbClr val="0F2040"/>
-                </a:solidFill>
-                <a:latin typeface="Calibri"/>
-              </a:rPr>
-              <a:t>Configurar todos los módulos del sistema</a:t>
+              </a:rPr>
+              <a:t>Acceso a TODOS los módulos sin excepción</a:t>
             </a:r>
           </a:p>
         </p:txBody>
@@ -5084,7 +5871,7 @@
                 </a:solidFill>
                 <a:latin typeface="Calibri"/>
               </a:rPr>
-              <a:t>Módulos que puedes ver</a:t>
+              <a:t>Dashboard del Administrador</a:t>
             </a:r>
           </a:p>
         </p:txBody>
@@ -5124,16 +5911,40 @@
           </a:p>
         </p:txBody>
       </p:sp>
-      <p:sp>
-        <p:nvSpPr>
-          <p:cNvPr id="5" name="TextBox 4"/>
+      <p:pic>
+        <p:nvPicPr>
+          <p:cNvPr id="5" name="Picture 4" descr="02_dashboard.png"/>
+          <p:cNvPicPr>
+            <a:picLocks noChangeAspect="1"/>
+          </p:cNvPicPr>
+          <p:nvPr/>
+        </p:nvPicPr>
+        <p:blipFill>
+          <a:blip r:embed="rId2"/>
+          <a:stretch>
+            <a:fillRect/>
+          </a:stretch>
+        </p:blipFill>
+        <p:spPr>
+          <a:xfrm>
+            <a:off x="1386687" y="1097280"/>
+            <a:ext cx="9418320" cy="5886450"/>
+          </a:xfrm>
+          <a:prstGeom prst="rect">
+            <a:avLst/>
+          </a:prstGeom>
+        </p:spPr>
+      </p:pic>
+      <p:sp>
+        <p:nvSpPr>
+          <p:cNvPr id="6" name="TextBox 5"/>
           <p:cNvSpPr txBox="1"/>
           <p:nvPr/>
         </p:nvSpPr>
         <p:spPr>
           <a:xfrm>
-            <a:off x="457200" y="1005840"/>
-            <a:ext cx="11247120" cy="731520"/>
+            <a:off x="914400" y="6035040"/>
+            <a:ext cx="10332720" cy="457200"/>
           </a:xfrm>
           <a:prstGeom prst="rect">
             <a:avLst/>
@@ -5141,351 +5952,20 @@
           <a:noFill/>
         </p:spPr>
         <p:txBody>
-          <a:bodyPr wrap="square" anchor="t" lIns="45720" rIns="45720">
+          <a:bodyPr wrap="square" anchor="ctr" lIns="45720" rIns="45720">
             <a:spAutoFit/>
           </a:bodyPr>
           <a:lstStyle/>
           <a:p>
-            <a:pPr algn="l"/>
-            <a:r>
-              <a:rPr sz="1400" b="0">
+            <a:pPr algn="ctr"/>
+            <a:r>
+              <a:rPr sz="1200" b="0">
                 <a:solidFill>
                   <a:srgbClr val="666666"/>
                 </a:solidFill>
                 <a:latin typeface="Calibri"/>
               </a:rPr>
-              <a:t>Tienes acceso a TODOS los módulos del sistema sin excepción:</a:t>
-            </a:r>
-          </a:p>
-        </p:txBody>
-      </p:sp>
-      <p:sp>
-        <p:nvSpPr>
-          <p:cNvPr id="6" name="TextBox 5"/>
-          <p:cNvSpPr txBox="1"/>
-          <p:nvPr/>
-        </p:nvSpPr>
-        <p:spPr>
-          <a:xfrm>
-            <a:off x="640080" y="1828800"/>
-            <a:ext cx="10972800" cy="4572000"/>
-          </a:xfrm>
-          <a:prstGeom prst="rect">
-            <a:avLst/>
-          </a:prstGeom>
-          <a:noFill/>
-        </p:spPr>
-        <p:txBody>
-          <a:bodyPr wrap="square">
-            <a:spAutoFit/>
-          </a:bodyPr>
-          <a:lstStyle/>
-          <a:p>
-            <a:pPr algn="l">
-              <a:lnSpc>
-                <a:spcPct val="140000"/>
-              </a:lnSpc>
-              <a:spcAft>
-                <a:spcPts val="800"/>
-              </a:spcAft>
-            </a:pPr>
-            <a:r>
-              <a:rPr sz="1600" b="1">
-                <a:solidFill>
-                  <a:srgbClr val="F59E0B"/>
-                </a:solidFill>
-                <a:latin typeface="Calibri"/>
-              </a:rPr>
-              <a:t>● </a:t>
-            </a:r>
-            <a:r>
-              <a:rPr sz="1600">
-                <a:solidFill>
-                  <a:srgbClr val="0F2040"/>
-                </a:solidFill>
-                <a:latin typeface="Calibri"/>
-              </a:rPr>
-              <a:t>Dashboard con métricas globales</a:t>
-            </a:r>
-          </a:p>
-          <a:p>
-            <a:pPr algn="l">
-              <a:lnSpc>
-                <a:spcPct val="140000"/>
-              </a:lnSpc>
-              <a:spcAft>
-                <a:spcPts val="800"/>
-              </a:spcAft>
-            </a:pPr>
-            <a:r>
-              <a:rPr sz="1600" b="1">
-                <a:solidFill>
-                  <a:srgbClr val="F59E0B"/>
-                </a:solidFill>
-                <a:latin typeface="Calibri"/>
-              </a:rPr>
-              <a:t>● </a:t>
-            </a:r>
-            <a:r>
-              <a:rPr sz="1600">
-                <a:solidFill>
-                  <a:srgbClr val="0F2040"/>
-                </a:solidFill>
-                <a:latin typeface="Calibri"/>
-              </a:rPr>
-              <a:t>Órdenes de Trabajo + Aprobaciones OT</a:t>
-            </a:r>
-          </a:p>
-          <a:p>
-            <a:pPr algn="l">
-              <a:lnSpc>
-                <a:spcPct val="140000"/>
-              </a:lnSpc>
-              <a:spcAft>
-                <a:spcPts val="800"/>
-              </a:spcAft>
-            </a:pPr>
-            <a:r>
-              <a:rPr sz="1600" b="1">
-                <a:solidFill>
-                  <a:srgbClr val="F59E0B"/>
-                </a:solidFill>
-                <a:latin typeface="Calibri"/>
-              </a:rPr>
-              <a:t>● </a:t>
-            </a:r>
-            <a:r>
-              <a:rPr sz="1600">
-                <a:solidFill>
-                  <a:srgbClr val="0F2040"/>
-                </a:solidFill>
-                <a:latin typeface="Calibri"/>
-              </a:rPr>
-              <a:t>Proyectos (con Informe de Costos)</a:t>
-            </a:r>
-          </a:p>
-          <a:p>
-            <a:pPr algn="l">
-              <a:lnSpc>
-                <a:spcPct val="140000"/>
-              </a:lnSpc>
-              <a:spcAft>
-                <a:spcPts val="800"/>
-              </a:spcAft>
-            </a:pPr>
-            <a:r>
-              <a:rPr sz="1600" b="1">
-                <a:solidFill>
-                  <a:srgbClr val="F59E0B"/>
-                </a:solidFill>
-                <a:latin typeface="Calibri"/>
-              </a:rPr>
-              <a:t>● </a:t>
-            </a:r>
-            <a:r>
-              <a:rPr sz="1600">
-                <a:solidFill>
-                  <a:srgbClr val="0F2040"/>
-                </a:solidFill>
-                <a:latin typeface="Calibri"/>
-              </a:rPr>
-              <a:t>Inspecciones, Personal, Asistencia, Activos</a:t>
-            </a:r>
-          </a:p>
-          <a:p>
-            <a:pPr algn="l">
-              <a:lnSpc>
-                <a:spcPct val="140000"/>
-              </a:lnSpc>
-              <a:spcAft>
-                <a:spcPts val="800"/>
-              </a:spcAft>
-            </a:pPr>
-            <a:r>
-              <a:rPr sz="1600" b="1">
-                <a:solidFill>
-                  <a:srgbClr val="F59E0B"/>
-                </a:solidFill>
-                <a:latin typeface="Calibri"/>
-              </a:rPr>
-              <a:t>● </a:t>
-            </a:r>
-            <a:r>
-              <a:rPr sz="1600">
-                <a:solidFill>
-                  <a:srgbClr val="0F2040"/>
-                </a:solidFill>
-                <a:latin typeface="Calibri"/>
-              </a:rPr>
-              <a:t>Inventario, Solicitud de Compras</a:t>
-            </a:r>
-          </a:p>
-          <a:p>
-            <a:pPr algn="l">
-              <a:lnSpc>
-                <a:spcPct val="140000"/>
-              </a:lnSpc>
-              <a:spcAft>
-                <a:spcPts val="800"/>
-              </a:spcAft>
-            </a:pPr>
-            <a:r>
-              <a:rPr sz="1600" b="1">
-                <a:solidFill>
-                  <a:srgbClr val="F59E0B"/>
-                </a:solidFill>
-                <a:latin typeface="Calibri"/>
-              </a:rPr>
-              <a:t>● </a:t>
-            </a:r>
-            <a:r>
-              <a:rPr sz="1600">
-                <a:solidFill>
-                  <a:srgbClr val="0F2040"/>
-                </a:solidFill>
-                <a:latin typeface="Calibri"/>
-              </a:rPr>
-              <a:t>Proveedores, Centro de Costos</a:t>
-            </a:r>
-          </a:p>
-          <a:p>
-            <a:pPr algn="l">
-              <a:lnSpc>
-                <a:spcPct val="140000"/>
-              </a:lnSpc>
-              <a:spcAft>
-                <a:spcPts val="800"/>
-              </a:spcAft>
-            </a:pPr>
-            <a:r>
-              <a:rPr sz="1600" b="1">
-                <a:solidFill>
-                  <a:srgbClr val="F59E0B"/>
-                </a:solidFill>
-                <a:latin typeface="Calibri"/>
-              </a:rPr>
-              <a:t>● </a:t>
-            </a:r>
-            <a:r>
-              <a:rPr sz="1600">
-                <a:solidFill>
-                  <a:srgbClr val="0F2040"/>
-                </a:solidFill>
-                <a:latin typeface="Calibri"/>
-              </a:rPr>
-              <a:t>Materiales, Tareas, Herramientas (Catálogos)</a:t>
-            </a:r>
-          </a:p>
-          <a:p>
-            <a:pPr algn="l">
-              <a:lnSpc>
-                <a:spcPct val="140000"/>
-              </a:lnSpc>
-              <a:spcAft>
-                <a:spcPts val="800"/>
-              </a:spcAft>
-            </a:pPr>
-            <a:r>
-              <a:rPr sz="1600" b="1">
-                <a:solidFill>
-                  <a:srgbClr val="F59E0B"/>
-                </a:solidFill>
-                <a:latin typeface="Calibri"/>
-              </a:rPr>
-              <a:t>● </a:t>
-            </a:r>
-            <a:r>
-              <a:rPr sz="1600">
-                <a:solidFill>
-                  <a:srgbClr val="0F2040"/>
-                </a:solidFill>
-                <a:latin typeface="Calibri"/>
-              </a:rPr>
-              <a:t>Cumplimiento Legal, Respaldos</a:t>
-            </a:r>
-          </a:p>
-          <a:p>
-            <a:pPr algn="l">
-              <a:lnSpc>
-                <a:spcPct val="140000"/>
-              </a:lnSpc>
-              <a:spcAft>
-                <a:spcPts val="800"/>
-              </a:spcAft>
-            </a:pPr>
-            <a:r>
-              <a:rPr sz="1600" b="1">
-                <a:solidFill>
-                  <a:srgbClr val="F59E0B"/>
-                </a:solidFill>
-                <a:latin typeface="Calibri"/>
-              </a:rPr>
-              <a:t>● </a:t>
-            </a:r>
-            <a:r>
-              <a:rPr sz="1600">
-                <a:solidFill>
-                  <a:srgbClr val="0F2040"/>
-                </a:solidFill>
-                <a:latin typeface="Calibri"/>
-              </a:rPr>
-              <a:t>Reportes, Auditoría, Notificaciones</a:t>
-            </a:r>
-          </a:p>
-          <a:p>
-            <a:pPr algn="l">
-              <a:lnSpc>
-                <a:spcPct val="140000"/>
-              </a:lnSpc>
-              <a:spcAft>
-                <a:spcPts val="800"/>
-              </a:spcAft>
-            </a:pPr>
-            <a:r>
-              <a:rPr sz="1600" b="1">
-                <a:solidFill>
-                  <a:srgbClr val="F59E0B"/>
-                </a:solidFill>
-                <a:latin typeface="Calibri"/>
-              </a:rPr>
-              <a:t>● </a:t>
-            </a:r>
-            <a:r>
-              <a:rPr sz="1600">
-                <a:solidFill>
-                  <a:srgbClr val="0F2040"/>
-                </a:solidFill>
-                <a:latin typeface="Calibri"/>
-              </a:rPr>
-              <a:t>Usuarios + Permisos del Sistema (exclusivo admin)</a:t>
-            </a:r>
-          </a:p>
-          <a:p>
-            <a:pPr algn="l">
-              <a:lnSpc>
-                <a:spcPct val="140000"/>
-              </a:lnSpc>
-              <a:spcAft>
-                <a:spcPts val="800"/>
-              </a:spcAft>
-            </a:pPr>
-            <a:r>
-              <a:rPr sz="1600" b="1">
-                <a:solidFill>
-                  <a:srgbClr val="F59E0B"/>
-                </a:solidFill>
-                <a:latin typeface="Calibri"/>
-              </a:rPr>
-              <a:t>● </a:t>
-            </a:r>
-            <a:r>
-              <a:rPr sz="1600">
-                <a:solidFill>
-                  <a:srgbClr val="0F2040"/>
-                </a:solidFill>
-                <a:latin typeface="Calibri"/>
-              </a:rPr>
-              <a:t>Rondas (ver, registrar, crear, editar, eliminar)</a:t>
+              <a:t>Vista general del Dashboard con métricas del sistema</a:t>
             </a:r>
           </a:p>
         </p:txBody>
@@ -5618,7 +6098,7 @@
     <p:bg>
       <p:bgPr>
         <a:solidFill>
-          <a:srgbClr val="0F2040"/>
+          <a:srgbClr val="FFFFFF"/>
         </a:solidFill>
         <a:effectLst/>
       </p:bgPr>
@@ -5638,14 +6118,14 @@
         </p:nvSpPr>
         <p:spPr>
           <a:xfrm>
-            <a:off x="0" y="3108960"/>
-            <a:ext cx="12191695" cy="73152"/>
+            <a:off x="0" y="0"/>
+            <a:ext cx="12191695" cy="822960"/>
           </a:xfrm>
           <a:prstGeom prst="rect">
             <a:avLst/>
           </a:prstGeom>
           <a:solidFill>
-            <a:srgbClr val="F59E0B"/>
+            <a:srgbClr val="0A1172"/>
           </a:solidFill>
           <a:ln>
             <a:noFill/>
@@ -5682,8 +6162,8 @@
         </p:nvSpPr>
         <p:spPr>
           <a:xfrm>
-            <a:off x="731520" y="2560320"/>
-            <a:ext cx="10698480" cy="640080"/>
+            <a:off x="365760" y="137160"/>
+            <a:ext cx="10058400" cy="548640"/>
           </a:xfrm>
           <a:prstGeom prst="rect">
             <a:avLst/>
@@ -5696,22 +6176,116 @@
           </a:bodyPr>
           <a:lstStyle/>
           <a:p>
+            <a:pPr algn="l"/>
+            <a:r>
+              <a:rPr sz="2200" b="1">
+                <a:solidFill>
+                  <a:srgbClr val="FFFFFF"/>
+                </a:solidFill>
+                <a:latin typeface="Calibri"/>
+              </a:rPr>
+              <a:t>Gestión de Usuarios</a:t>
+            </a:r>
+          </a:p>
+        </p:txBody>
+      </p:sp>
+      <p:sp>
+        <p:nvSpPr>
+          <p:cNvPr id="4" name="TextBox 3"/>
+          <p:cNvSpPr txBox="1"/>
+          <p:nvPr/>
+        </p:nvSpPr>
+        <p:spPr>
+          <a:xfrm>
+            <a:off x="11247120" y="137160"/>
+            <a:ext cx="731520" cy="548640"/>
+          </a:xfrm>
+          <a:prstGeom prst="rect">
+            <a:avLst/>
+          </a:prstGeom>
+          <a:noFill/>
+        </p:spPr>
+        <p:txBody>
+          <a:bodyPr wrap="square" anchor="ctr" lIns="45720" rIns="45720">
+            <a:spAutoFit/>
+          </a:bodyPr>
+          <a:lstStyle/>
+          <a:p>
+            <a:pPr algn="r"/>
+            <a:r>
+              <a:rPr sz="1400" b="0">
+                <a:solidFill>
+                  <a:srgbClr val="F59E0B"/>
+                </a:solidFill>
+                <a:latin typeface="Calibri"/>
+              </a:rPr>
+              <a:t>4</a:t>
+            </a:r>
+          </a:p>
+        </p:txBody>
+      </p:sp>
+      <p:pic>
+        <p:nvPicPr>
+          <p:cNvPr id="5" name="Picture 4" descr="07_usuarios.png"/>
+          <p:cNvPicPr>
+            <a:picLocks noChangeAspect="1"/>
+          </p:cNvPicPr>
+          <p:nvPr/>
+        </p:nvPicPr>
+        <p:blipFill>
+          <a:blip r:embed="rId2"/>
+          <a:stretch>
+            <a:fillRect/>
+          </a:stretch>
+        </p:blipFill>
+        <p:spPr>
+          <a:xfrm>
+            <a:off x="1386687" y="1097280"/>
+            <a:ext cx="9418320" cy="5886450"/>
+          </a:xfrm>
+          <a:prstGeom prst="rect">
+            <a:avLst/>
+          </a:prstGeom>
+        </p:spPr>
+      </p:pic>
+      <p:sp>
+        <p:nvSpPr>
+          <p:cNvPr id="6" name="TextBox 5"/>
+          <p:cNvSpPr txBox="1"/>
+          <p:nvPr/>
+        </p:nvSpPr>
+        <p:spPr>
+          <a:xfrm>
+            <a:off x="914400" y="6035040"/>
+            <a:ext cx="10332720" cy="457200"/>
+          </a:xfrm>
+          <a:prstGeom prst="rect">
+            <a:avLst/>
+          </a:prstGeom>
+          <a:noFill/>
+        </p:spPr>
+        <p:txBody>
+          <a:bodyPr wrap="square" anchor="ctr" lIns="45720" rIns="45720">
+            <a:spAutoFit/>
+          </a:bodyPr>
+          <a:lstStyle/>
+          <a:p>
             <a:pPr algn="ctr"/>
             <a:r>
-              <a:rPr sz="3600" b="1">
-                <a:solidFill>
-                  <a:srgbClr val="FFFFFF"/>
+              <a:rPr sz="1200" b="0">
+                <a:solidFill>
+                  <a:srgbClr val="666666"/>
                 </a:solidFill>
                 <a:latin typeface="Calibri"/>
               </a:rPr>
-              <a:t>Flujos que gestionas</a:t>
-            </a:r>
-          </a:p>
-        </p:txBody>
-      </p:sp>
-      <p:sp>
-        <p:nvSpPr>
-          <p:cNvPr id="4" name="Rectangle 3"/>
+              <a:t>Módulo de Usuarios — solo visible para Administrador</a:t>
+            </a:r>
+          </a:p>
+        </p:txBody>
+      </p:sp>
+      <p:sp>
+        <p:nvSpPr>
+          <p:cNvPr id="7" name="Rectangle 6"/>
           <p:cNvSpPr/>
           <p:nvPr/>
         </p:nvSpPr>
@@ -5755,7 +6329,7 @@
       </p:sp>
       <p:sp>
         <p:nvSpPr>
-          <p:cNvPr id="5" name="TextBox 4"/>
+          <p:cNvPr id="8" name="TextBox 7"/>
           <p:cNvSpPr txBox="1"/>
           <p:nvPr/>
         </p:nvSpPr>
@@ -5790,7 +6364,7 @@
       </p:sp>
       <p:sp>
         <p:nvSpPr>
-          <p:cNvPr id="6" name="TextBox 5"/>
+          <p:cNvPr id="9" name="TextBox 8"/>
           <p:cNvSpPr txBox="1"/>
           <p:nvPr/>
         </p:nvSpPr>
@@ -5923,7 +6497,7 @@
                 </a:solidFill>
                 <a:latin typeface="Calibri"/>
               </a:rPr>
-              <a:t>Flujo: Crear Usuario</a:t>
+              <a:t>Crear Nuevo Usuario</a:t>
             </a:r>
           </a:p>
         </p:txBody>
@@ -5963,16 +6537,40 @@
           </a:p>
         </p:txBody>
       </p:sp>
-      <p:sp>
-        <p:nvSpPr>
-          <p:cNvPr id="5" name="TextBox 4"/>
+      <p:pic>
+        <p:nvPicPr>
+          <p:cNvPr id="5" name="Picture 4" descr="12_usuario_crear.png"/>
+          <p:cNvPicPr>
+            <a:picLocks noChangeAspect="1"/>
+          </p:cNvPicPr>
+          <p:nvPr/>
+        </p:nvPicPr>
+        <p:blipFill>
+          <a:blip r:embed="rId2"/>
+          <a:stretch>
+            <a:fillRect/>
+          </a:stretch>
+        </p:blipFill>
+        <p:spPr>
+          <a:xfrm>
+            <a:off x="1386687" y="1097280"/>
+            <a:ext cx="9418320" cy="5886450"/>
+          </a:xfrm>
+          <a:prstGeom prst="rect">
+            <a:avLst/>
+          </a:prstGeom>
+        </p:spPr>
+      </p:pic>
+      <p:sp>
+        <p:nvSpPr>
+          <p:cNvPr id="6" name="TextBox 5"/>
           <p:cNvSpPr txBox="1"/>
           <p:nvPr/>
         </p:nvSpPr>
         <p:spPr>
           <a:xfrm>
-            <a:off x="457200" y="1005840"/>
-            <a:ext cx="11247120" cy="548640"/>
+            <a:off x="914400" y="6035040"/>
+            <a:ext cx="10332720" cy="457200"/>
           </a:xfrm>
           <a:prstGeom prst="rect">
             <a:avLst/>
@@ -5980,239 +6578,20 @@
           <a:noFill/>
         </p:spPr>
         <p:txBody>
-          <a:bodyPr wrap="square" anchor="t" lIns="45720" rIns="45720">
+          <a:bodyPr wrap="square" anchor="ctr" lIns="45720" rIns="45720">
             <a:spAutoFit/>
           </a:bodyPr>
           <a:lstStyle/>
           <a:p>
-            <a:pPr algn="l"/>
-            <a:r>
-              <a:rPr sz="1400" b="0">
+            <a:pPr algn="ctr"/>
+            <a:r>
+              <a:rPr sz="1200" b="0">
                 <a:solidFill>
                   <a:srgbClr val="666666"/>
                 </a:solidFill>
                 <a:latin typeface="Calibri"/>
               </a:rPr>
-              <a:t>Pasos para crear un nuevo usuario en el sistema:</a:t>
-            </a:r>
-          </a:p>
-        </p:txBody>
-      </p:sp>
-      <p:sp>
-        <p:nvSpPr>
-          <p:cNvPr id="6" name="TextBox 5"/>
-          <p:cNvSpPr txBox="1"/>
-          <p:nvPr/>
-        </p:nvSpPr>
-        <p:spPr>
-          <a:xfrm>
-            <a:off x="640080" y="1645920"/>
-            <a:ext cx="10972800" cy="4572000"/>
-          </a:xfrm>
-          <a:prstGeom prst="rect">
-            <a:avLst/>
-          </a:prstGeom>
-          <a:noFill/>
-        </p:spPr>
-        <p:txBody>
-          <a:bodyPr wrap="square">
-            <a:spAutoFit/>
-          </a:bodyPr>
-          <a:lstStyle/>
-          <a:p>
-            <a:pPr algn="l">
-              <a:lnSpc>
-                <a:spcPct val="150000"/>
-              </a:lnSpc>
-              <a:spcAft>
-                <a:spcPts val="1000"/>
-              </a:spcAft>
-            </a:pPr>
-            <a:r>
-              <a:rPr sz="2000" b="1">
-                <a:solidFill>
-                  <a:srgbClr val="F59E0B"/>
-                </a:solidFill>
-                <a:latin typeface="Calibri"/>
-              </a:rPr>
-              <a:t>1.  </a:t>
-            </a:r>
-            <a:r>
-              <a:rPr sz="1600">
-                <a:solidFill>
-                  <a:srgbClr val="0F2040"/>
-                </a:solidFill>
-                <a:latin typeface="Calibri"/>
-              </a:rPr>
-              <a:t>Ve a Sistema → Usuarios → "Crear Usuario"</a:t>
-            </a:r>
-          </a:p>
-          <a:p>
-            <a:pPr algn="l">
-              <a:lnSpc>
-                <a:spcPct val="150000"/>
-              </a:lnSpc>
-              <a:spcAft>
-                <a:spcPts val="1000"/>
-              </a:spcAft>
-            </a:pPr>
-            <a:r>
-              <a:rPr sz="2000" b="1">
-                <a:solidFill>
-                  <a:srgbClr val="F59E0B"/>
-                </a:solidFill>
-                <a:latin typeface="Calibri"/>
-              </a:rPr>
-              <a:t>2.  </a:t>
-            </a:r>
-            <a:r>
-              <a:rPr sz="1600">
-                <a:solidFill>
-                  <a:srgbClr val="0F2040"/>
-                </a:solidFill>
-                <a:latin typeface="Calibri"/>
-              </a:rPr>
-              <a:t>Completa: nombre, apellido, email, RUT, rol</a:t>
-            </a:r>
-          </a:p>
-          <a:p>
-            <a:pPr algn="l">
-              <a:lnSpc>
-                <a:spcPct val="150000"/>
-              </a:lnSpc>
-              <a:spcAft>
-                <a:spcPts val="1000"/>
-              </a:spcAft>
-            </a:pPr>
-            <a:r>
-              <a:rPr sz="2000" b="1">
-                <a:solidFill>
-                  <a:srgbClr val="F59E0B"/>
-                </a:solidFill>
-                <a:latin typeface="Calibri"/>
-              </a:rPr>
-              <a:t>3.  </a:t>
-            </a:r>
-            <a:r>
-              <a:rPr sz="1600">
-                <a:solidFill>
-                  <a:srgbClr val="0F2040"/>
-                </a:solidFill>
-                <a:latin typeface="Calibri"/>
-              </a:rPr>
-              <a:t>Asigna contraseña temporal (mínimo 8 caracteres)</a:t>
-            </a:r>
-          </a:p>
-          <a:p>
-            <a:pPr algn="l">
-              <a:lnSpc>
-                <a:spcPct val="150000"/>
-              </a:lnSpc>
-              <a:spcAft>
-                <a:spcPts val="1000"/>
-              </a:spcAft>
-            </a:pPr>
-            <a:r>
-              <a:rPr sz="2000" b="1">
-                <a:solidFill>
-                  <a:srgbClr val="F59E0B"/>
-                </a:solidFill>
-                <a:latin typeface="Calibri"/>
-              </a:rPr>
-              <a:t>4.  </a:t>
-            </a:r>
-            <a:r>
-              <a:rPr sz="1600">
-                <a:solidFill>
-                  <a:srgbClr val="0F2040"/>
-                </a:solidFill>
-                <a:latin typeface="Calibri"/>
-              </a:rPr>
-              <a:t>Configura permisos personalizados (opcional)</a:t>
-            </a:r>
-          </a:p>
-          <a:p>
-            <a:pPr algn="l">
-              <a:lnSpc>
-                <a:spcPct val="150000"/>
-              </a:lnSpc>
-              <a:spcAft>
-                <a:spcPts val="1000"/>
-              </a:spcAft>
-            </a:pPr>
-            <a:r>
-              <a:rPr sz="2000" b="1">
-                <a:solidFill>
-                  <a:srgbClr val="F59E0B"/>
-                </a:solidFill>
-                <a:latin typeface="Calibri"/>
-              </a:rPr>
-              <a:t>5.  </a:t>
-            </a:r>
-            <a:r>
-              <a:rPr sz="1600">
-                <a:solidFill>
-                  <a:srgbClr val="0F2040"/>
-                </a:solidFill>
-                <a:latin typeface="Calibri"/>
-              </a:rPr>
-              <a:t>Guarda → aparece diálogo con credenciales</a:t>
-            </a:r>
-          </a:p>
-          <a:p>
-            <a:pPr algn="l">
-              <a:lnSpc>
-                <a:spcPct val="150000"/>
-              </a:lnSpc>
-              <a:spcAft>
-                <a:spcPts val="1000"/>
-              </a:spcAft>
-            </a:pPr>
-            <a:r>
-              <a:rPr sz="2000" b="1">
-                <a:solidFill>
-                  <a:srgbClr val="F59E0B"/>
-                </a:solidFill>
-                <a:latin typeface="Calibri"/>
-              </a:rPr>
-              <a:t>6.  </a:t>
-            </a:r>
-            <a:r>
-              <a:rPr sz="1600">
-                <a:solidFill>
-                  <a:srgbClr val="0F2040"/>
-                </a:solidFill>
-                <a:latin typeface="Calibri"/>
-              </a:rPr>
-              <a:t>Comparte credenciales con el usuario por canal seguro</a:t>
-            </a:r>
-          </a:p>
-          <a:p>
-            <a:pPr algn="l">
-              <a:lnSpc>
-                <a:spcPct val="150000"/>
-              </a:lnSpc>
-              <a:spcAft>
-                <a:spcPts val="1000"/>
-              </a:spcAft>
-            </a:pPr>
-            <a:r>
-              <a:rPr sz="2000" b="1">
-                <a:solidFill>
-                  <a:srgbClr val="F59E0B"/>
-                </a:solidFill>
-                <a:latin typeface="Calibri"/>
-              </a:rPr>
-              <a:t>7.  </a:t>
-            </a:r>
-            <a:r>
-              <a:rPr sz="1600">
-                <a:solidFill>
-                  <a:srgbClr val="0F2040"/>
-                </a:solidFill>
-                <a:latin typeface="Calibri"/>
-              </a:rPr>
-              <a:t>El usuario deberá cambiar su contraseña en el primer login</a:t>
+              <a:t>Formulario de creación de usuario con selección de rol y permisos</a:t>
             </a:r>
           </a:p>
         </p:txBody>
@@ -6431,7 +6810,7 @@
                 </a:solidFill>
                 <a:latin typeface="Calibri"/>
               </a:rPr>
-              <a:t>Flujo: Aprobar Solicitud de Compra</a:t>
+              <a:t>Flujo: Crear Usuario</a:t>
             </a:r>
           </a:p>
         </p:txBody>
@@ -6501,7 +6880,7 @@
                 </a:solidFill>
                 <a:latin typeface="Calibri"/>
               </a:rPr>
-              <a:t>Como admin, apruebas en la 2da etapa del flujo:</a:t>
+              <a:t>Pasos para crear un nuevo usuario:</a:t>
             </a:r>
           </a:p>
         </p:txBody>
@@ -6541,7 +6920,6 @@
                 <a:solidFill>
                   <a:srgbClr val="F59E0B"/>
                 </a:solidFill>
-                <a:latin typeface="Calibri"/>
               </a:rPr>
               <a:t>1.  </a:t>
             </a:r>
@@ -6550,9 +6928,8 @@
                 <a:solidFill>
                   <a:srgbClr val="0F2040"/>
                 </a:solidFill>
-                <a:latin typeface="Calibri"/>
-              </a:rPr>
-              <a:t>Ve a Solicitud de Compras</a:t>
+              </a:rPr>
+              <a:t>Ve a Sistema → Usuarios → "Crear Usuario"</a:t>
             </a:r>
           </a:p>
           <a:p>
@@ -6569,7 +6946,6 @@
                 <a:solidFill>
                   <a:srgbClr val="F59E0B"/>
                 </a:solidFill>
-                <a:latin typeface="Calibri"/>
               </a:rPr>
               <a:t>2.  </a:t>
             </a:r>
@@ -6578,9 +6954,8 @@
                 <a:solidFill>
                   <a:srgbClr val="0F2040"/>
                 </a:solidFill>
-                <a:latin typeface="Calibri"/>
-              </a:rPr>
-              <a:t>Busca SC con etapa "Aprobada Supervisor" (el supervisor ya aprobó)</a:t>
+              </a:rPr>
+              <a:t>Completa: nombre, apellido, email, RUT, rol</a:t>
             </a:r>
           </a:p>
           <a:p>
@@ -6597,7 +6972,6 @@
                 <a:solidFill>
                   <a:srgbClr val="F59E0B"/>
                 </a:solidFill>
-                <a:latin typeface="Calibri"/>
               </a:rPr>
               <a:t>3.  </a:t>
             </a:r>
@@ -6606,9 +6980,8 @@
                 <a:solidFill>
                   <a:srgbClr val="0F2040"/>
                 </a:solidFill>
-                <a:latin typeface="Calibri"/>
-              </a:rPr>
-              <a:t>Revisa materiales, monto, proveedor sugerido</a:t>
+              </a:rPr>
+              <a:t>Asigna contraseña temporal (mínimo 8 caracteres)</a:t>
             </a:r>
           </a:p>
           <a:p>
@@ -6625,7 +6998,6 @@
                 <a:solidFill>
                   <a:srgbClr val="F59E0B"/>
                 </a:solidFill>
-                <a:latin typeface="Calibri"/>
               </a:rPr>
               <a:t>4.  </a:t>
             </a:r>
@@ -6634,9 +7006,8 @@
                 <a:solidFill>
                   <a:srgbClr val="0F2040"/>
                 </a:solidFill>
-                <a:latin typeface="Calibri"/>
-              </a:rPr>
-              <a:t>Haz clic en "Gestionar" (botón verde)</a:t>
+              </a:rPr>
+              <a:t>Configura permisos personalizados (opcional)</a:t>
             </a:r>
           </a:p>
           <a:p>
@@ -6653,7 +7024,6 @@
                 <a:solidFill>
                   <a:srgbClr val="F59E0B"/>
                 </a:solidFill>
-                <a:latin typeface="Calibri"/>
               </a:rPr>
               <a:t>5.  </a:t>
             </a:r>
@@ -6662,9 +7032,8 @@
                 <a:solidFill>
                   <a:srgbClr val="0F2040"/>
                 </a:solidFill>
-                <a:latin typeface="Calibri"/>
-              </a:rPr>
-              <a:t>Opcional: agrega observaciones</a:t>
+              </a:rPr>
+              <a:t>Guarda → aparece diálogo con credenciales</a:t>
             </a:r>
           </a:p>
           <a:p>
@@ -6681,7 +7050,6 @@
                 <a:solidFill>
                   <a:srgbClr val="F59E0B"/>
                 </a:solidFill>
-                <a:latin typeface="Calibri"/>
               </a:rPr>
               <a:t>6.  </a:t>
             </a:r>
@@ -6690,9 +7058,8 @@
                 <a:solidFill>
                   <a:srgbClr val="0F2040"/>
                 </a:solidFill>
-                <a:latin typeface="Calibri"/>
-              </a:rPr>
-              <a:t>Confirma → estado pasa a "En Proceso"</a:t>
+              </a:rPr>
+              <a:t>Comparte credenciales con el usuario por canal seguro</a:t>
             </a:r>
           </a:p>
           <a:p>
@@ -6709,7 +7076,6 @@
                 <a:solidFill>
                   <a:srgbClr val="F59E0B"/>
                 </a:solidFill>
-                <a:latin typeface="Calibri"/>
               </a:rPr>
               <a:t>7.  </a:t>
             </a:r>
@@ -6718,9 +7084,8 @@
                 <a:solidFill>
                   <a:srgbClr val="0F2040"/>
                 </a:solidFill>
-                <a:latin typeface="Calibri"/>
-              </a:rPr>
-              <a:t>Cuando compres los materiales, edita la SC → estado "Comprado"</a:t>
+              </a:rPr>
+              <a:t>El usuario deberá cambiar su contraseña en el primer login</a:t>
             </a:r>
           </a:p>
         </p:txBody>
@@ -6939,7 +7304,7 @@
                 </a:solidFill>
                 <a:latin typeface="Calibri"/>
               </a:rPr>
-              <a:t>Flujo: Aprobar OT Completada</a:t>
+              <a:t>Permisos del Sistema</a:t>
             </a:r>
           </a:p>
         </p:txBody>
@@ -6979,16 +7344,40 @@
           </a:p>
         </p:txBody>
       </p:sp>
-      <p:sp>
-        <p:nvSpPr>
-          <p:cNvPr id="5" name="TextBox 4"/>
+      <p:pic>
+        <p:nvPicPr>
+          <p:cNvPr id="5" name="Picture 4" descr="08_permisos.png"/>
+          <p:cNvPicPr>
+            <a:picLocks noChangeAspect="1"/>
+          </p:cNvPicPr>
+          <p:nvPr/>
+        </p:nvPicPr>
+        <p:blipFill>
+          <a:blip r:embed="rId2"/>
+          <a:stretch>
+            <a:fillRect/>
+          </a:stretch>
+        </p:blipFill>
+        <p:spPr>
+          <a:xfrm>
+            <a:off x="1386687" y="1097280"/>
+            <a:ext cx="9418320" cy="5886450"/>
+          </a:xfrm>
+          <a:prstGeom prst="rect">
+            <a:avLst/>
+          </a:prstGeom>
+        </p:spPr>
+      </p:pic>
+      <p:sp>
+        <p:nvSpPr>
+          <p:cNvPr id="6" name="TextBox 5"/>
           <p:cNvSpPr txBox="1"/>
           <p:nvPr/>
         </p:nvSpPr>
         <p:spPr>
           <a:xfrm>
-            <a:off x="457200" y="1005840"/>
-            <a:ext cx="11247120" cy="548640"/>
+            <a:off x="914400" y="6035040"/>
+            <a:ext cx="10332720" cy="457200"/>
           </a:xfrm>
           <a:prstGeom prst="rect">
             <a:avLst/>
@@ -6996,239 +7385,20 @@
           <a:noFill/>
         </p:spPr>
         <p:txBody>
-          <a:bodyPr wrap="square" anchor="t" lIns="45720" rIns="45720">
+          <a:bodyPr wrap="square" anchor="ctr" lIns="45720" rIns="45720">
             <a:spAutoFit/>
           </a:bodyPr>
           <a:lstStyle/>
           <a:p>
-            <a:pPr algn="l"/>
-            <a:r>
-              <a:rPr sz="1400" b="0">
+            <a:pPr algn="ctr"/>
+            <a:r>
+              <a:rPr sz="1200" b="0">
                 <a:solidFill>
                   <a:srgbClr val="666666"/>
                 </a:solidFill>
                 <a:latin typeface="Calibri"/>
               </a:rPr>
-              <a:t>Cuando un trabajador completa una OT, debes aprobarla o rechazarla:</a:t>
-            </a:r>
-          </a:p>
-        </p:txBody>
-      </p:sp>
-      <p:sp>
-        <p:nvSpPr>
-          <p:cNvPr id="6" name="TextBox 5"/>
-          <p:cNvSpPr txBox="1"/>
-          <p:nvPr/>
-        </p:nvSpPr>
-        <p:spPr>
-          <a:xfrm>
-            <a:off x="640080" y="1645920"/>
-            <a:ext cx="10972800" cy="4572000"/>
-          </a:xfrm>
-          <a:prstGeom prst="rect">
-            <a:avLst/>
-          </a:prstGeom>
-          <a:noFill/>
-        </p:spPr>
-        <p:txBody>
-          <a:bodyPr wrap="square">
-            <a:spAutoFit/>
-          </a:bodyPr>
-          <a:lstStyle/>
-          <a:p>
-            <a:pPr algn="l">
-              <a:lnSpc>
-                <a:spcPct val="150000"/>
-              </a:lnSpc>
-              <a:spcAft>
-                <a:spcPts val="1000"/>
-              </a:spcAft>
-            </a:pPr>
-            <a:r>
-              <a:rPr sz="2000" b="1">
-                <a:solidFill>
-                  <a:srgbClr val="F59E0B"/>
-                </a:solidFill>
-                <a:latin typeface="Calibri"/>
-              </a:rPr>
-              <a:t>1.  </a:t>
-            </a:r>
-            <a:r>
-              <a:rPr sz="1600">
-                <a:solidFill>
-                  <a:srgbClr val="0F2040"/>
-                </a:solidFill>
-                <a:latin typeface="Calibri"/>
-              </a:rPr>
-              <a:t>Ve a Aprobaciones OT</a:t>
-            </a:r>
-          </a:p>
-          <a:p>
-            <a:pPr algn="l">
-              <a:lnSpc>
-                <a:spcPct val="150000"/>
-              </a:lnSpc>
-              <a:spcAft>
-                <a:spcPts val="1000"/>
-              </a:spcAft>
-            </a:pPr>
-            <a:r>
-              <a:rPr sz="2000" b="1">
-                <a:solidFill>
-                  <a:srgbClr val="F59E0B"/>
-                </a:solidFill>
-                <a:latin typeface="Calibri"/>
-              </a:rPr>
-              <a:t>2.  </a:t>
-            </a:r>
-            <a:r>
-              <a:rPr sz="1600">
-                <a:solidFill>
-                  <a:srgbClr val="0F2040"/>
-                </a:solidFill>
-                <a:latin typeface="Calibri"/>
-              </a:rPr>
-              <a:t>Verás OTs en estado "Completado" con estadoAprobacion "Pendiente"</a:t>
-            </a:r>
-          </a:p>
-          <a:p>
-            <a:pPr algn="l">
-              <a:lnSpc>
-                <a:spcPct val="150000"/>
-              </a:lnSpc>
-              <a:spcAft>
-                <a:spcPts val="1000"/>
-              </a:spcAft>
-            </a:pPr>
-            <a:r>
-              <a:rPr sz="2000" b="1">
-                <a:solidFill>
-                  <a:srgbClr val="F59E0B"/>
-                </a:solidFill>
-                <a:latin typeface="Calibri"/>
-              </a:rPr>
-              <a:t>3.  </a:t>
-            </a:r>
-            <a:r>
-              <a:rPr sz="1600">
-                <a:solidFill>
-                  <a:srgbClr val="0F2040"/>
-                </a:solidFill>
-                <a:latin typeface="Calibri"/>
-              </a:rPr>
-              <a:t>Haz clic en la OT para revisar: materiales, tareas, fotos, observaciones</a:t>
-            </a:r>
-          </a:p>
-          <a:p>
-            <a:pPr algn="l">
-              <a:lnSpc>
-                <a:spcPct val="150000"/>
-              </a:lnSpc>
-              <a:spcAft>
-                <a:spcPts val="1000"/>
-              </a:spcAft>
-            </a:pPr>
-            <a:r>
-              <a:rPr sz="2000" b="1">
-                <a:solidFill>
-                  <a:srgbClr val="F59E0B"/>
-                </a:solidFill>
-                <a:latin typeface="Calibri"/>
-              </a:rPr>
-              <a:t>4.  </a:t>
-            </a:r>
-            <a:r>
-              <a:rPr sz="1600">
-                <a:solidFill>
-                  <a:srgbClr val="0F2040"/>
-                </a:solidFill>
-                <a:latin typeface="Calibri"/>
-              </a:rPr>
-              <a:t>Si todo está correcto: "Aprobar" (verde)</a:t>
-            </a:r>
-          </a:p>
-          <a:p>
-            <a:pPr algn="l">
-              <a:lnSpc>
-                <a:spcPct val="150000"/>
-              </a:lnSpc>
-              <a:spcAft>
-                <a:spcPts val="1000"/>
-              </a:spcAft>
-            </a:pPr>
-            <a:r>
-              <a:rPr sz="2000" b="1">
-                <a:solidFill>
-                  <a:srgbClr val="F59E0B"/>
-                </a:solidFill>
-                <a:latin typeface="Calibri"/>
-              </a:rPr>
-              <a:t>5.  </a:t>
-            </a:r>
-            <a:r>
-              <a:rPr sz="1600">
-                <a:solidFill>
-                  <a:srgbClr val="0F2040"/>
-                </a:solidFill>
-                <a:latin typeface="Calibri"/>
-              </a:rPr>
-              <a:t>Si hay problemas: "Rechazar" (rojo) + motivo obligatorio</a:t>
-            </a:r>
-          </a:p>
-          <a:p>
-            <a:pPr algn="l">
-              <a:lnSpc>
-                <a:spcPct val="150000"/>
-              </a:lnSpc>
-              <a:spcAft>
-                <a:spcPts val="1000"/>
-              </a:spcAft>
-            </a:pPr>
-            <a:r>
-              <a:rPr sz="2000" b="1">
-                <a:solidFill>
-                  <a:srgbClr val="F59E0B"/>
-                </a:solidFill>
-                <a:latin typeface="Calibri"/>
-              </a:rPr>
-              <a:t>6.  </a:t>
-            </a:r>
-            <a:r>
-              <a:rPr sz="1600">
-                <a:solidFill>
-                  <a:srgbClr val="0F2040"/>
-                </a:solidFill>
-                <a:latin typeface="Calibri"/>
-              </a:rPr>
-              <a:t>El trabajador verá el rechazo y deberá corregir</a:t>
-            </a:r>
-          </a:p>
-          <a:p>
-            <a:pPr algn="l">
-              <a:lnSpc>
-                <a:spcPct val="150000"/>
-              </a:lnSpc>
-              <a:spcAft>
-                <a:spcPts val="1000"/>
-              </a:spcAft>
-            </a:pPr>
-            <a:r>
-              <a:rPr sz="2000" b="1">
-                <a:solidFill>
-                  <a:srgbClr val="F59E0B"/>
-                </a:solidFill>
-                <a:latin typeface="Calibri"/>
-              </a:rPr>
-              <a:t>7.  </a:t>
-            </a:r>
-            <a:r>
-              <a:rPr sz="1600">
-                <a:solidFill>
-                  <a:srgbClr val="0F2040"/>
-                </a:solidFill>
-                <a:latin typeface="Calibri"/>
-              </a:rPr>
-              <a:t>Todo queda en el historial (Seguimiento de Aprobaciones)</a:t>
+              <a:t>Matriz visual de permisos — 15 categorías × 6 roles (exclusivo admin)</a:t>
             </a:r>
           </a:p>
         </p:txBody>
@@ -7447,7 +7617,7 @@
                 </a:solidFill>
                 <a:latin typeface="Calibri"/>
               </a:rPr>
-              <a:t>Módulo Permisos del Sistema</a:t>
+              <a:t>Solicitudes de Compra</a:t>
             </a:r>
           </a:p>
         </p:txBody>
@@ -7487,22 +7657,81 @@
           </a:p>
         </p:txBody>
       </p:sp>
-      <p:sp>
-        <p:nvSpPr>
-          <p:cNvPr id="5" name="Rounded Rectangle 4"/>
+      <p:pic>
+        <p:nvPicPr>
+          <p:cNvPr id="5" name="Picture 4" descr="06_solicitudes_compra.png"/>
+          <p:cNvPicPr>
+            <a:picLocks noChangeAspect="1"/>
+          </p:cNvPicPr>
+          <p:nvPr/>
+        </p:nvPicPr>
+        <p:blipFill>
+          <a:blip r:embed="rId2"/>
+          <a:stretch>
+            <a:fillRect/>
+          </a:stretch>
+        </p:blipFill>
+        <p:spPr>
+          <a:xfrm>
+            <a:off x="1386687" y="1097280"/>
+            <a:ext cx="9418320" cy="5886450"/>
+          </a:xfrm>
+          <a:prstGeom prst="rect">
+            <a:avLst/>
+          </a:prstGeom>
+        </p:spPr>
+      </p:pic>
+      <p:sp>
+        <p:nvSpPr>
+          <p:cNvPr id="6" name="TextBox 5"/>
+          <p:cNvSpPr txBox="1"/>
+          <p:nvPr/>
+        </p:nvSpPr>
+        <p:spPr>
+          <a:xfrm>
+            <a:off x="914400" y="6035040"/>
+            <a:ext cx="10332720" cy="457200"/>
+          </a:xfrm>
+          <a:prstGeom prst="rect">
+            <a:avLst/>
+          </a:prstGeom>
+          <a:noFill/>
+        </p:spPr>
+        <p:txBody>
+          <a:bodyPr wrap="square" anchor="ctr" lIns="45720" rIns="45720">
+            <a:spAutoFit/>
+          </a:bodyPr>
+          <a:lstStyle/>
+          <a:p>
+            <a:pPr algn="ctr"/>
+            <a:r>
+              <a:rPr sz="1200" b="0">
+                <a:solidFill>
+                  <a:srgbClr val="666666"/>
+                </a:solidFill>
+                <a:latin typeface="Calibri"/>
+              </a:rPr>
+              <a:t>Módulo SC con columna "Etapa Aprob." y botones de acción</a:t>
+            </a:r>
+          </a:p>
+        </p:txBody>
+      </p:sp>
+      <p:sp>
+        <p:nvSpPr>
+          <p:cNvPr id="7" name="Rectangle 6"/>
           <p:cNvSpPr/>
           <p:nvPr/>
         </p:nvSpPr>
         <p:spPr>
           <a:xfrm>
-            <a:off x="365760" y="1097280"/>
-            <a:ext cx="5577840" cy="548640"/>
-          </a:xfrm>
-          <a:prstGeom prst="roundRect">
+            <a:off x="0" y="6583680"/>
+            <a:ext cx="12191695" cy="274320"/>
+          </a:xfrm>
+          <a:prstGeom prst="rect">
             <a:avLst/>
           </a:prstGeom>
           <a:solidFill>
-            <a:srgbClr val="F59E0B"/>
+            <a:srgbClr val="0F2040"/>
           </a:solidFill>
           <a:ln>
             <a:noFill/>
@@ -7533,14 +7762,14 @@
       </p:sp>
       <p:sp>
         <p:nvSpPr>
-          <p:cNvPr id="6" name="TextBox 5"/>
+          <p:cNvPr id="8" name="TextBox 7"/>
           <p:cNvSpPr txBox="1"/>
           <p:nvPr/>
         </p:nvSpPr>
         <p:spPr>
           <a:xfrm>
-            <a:off x="365760" y="1097280"/>
-            <a:ext cx="5577840" cy="548640"/>
+            <a:off x="365760" y="6583680"/>
+            <a:ext cx="6400800" cy="274320"/>
           </a:xfrm>
           <a:prstGeom prst="rect">
             <a:avLst/>
@@ -7553,506 +7782,22 @@
           </a:bodyPr>
           <a:lstStyle/>
           <a:p>
-            <a:pPr algn="ctr"/>
-            <a:r>
-              <a:rPr sz="1800" b="1">
+            <a:pPr algn="l"/>
+            <a:r>
+              <a:rPr sz="900" b="0">
                 <a:solidFill>
                   <a:srgbClr val="FFFFFF"/>
                 </a:solidFill>
                 <a:latin typeface="Calibri"/>
               </a:rPr>
-              <a:t>Exclusivo del Administrador — matriz visual de permisos por rol:</a:t>
-            </a:r>
-          </a:p>
-        </p:txBody>
-      </p:sp>
-      <p:sp>
-        <p:nvSpPr>
-          <p:cNvPr id="7" name="TextBox 6"/>
-          <p:cNvSpPr txBox="1"/>
-          <p:nvPr/>
-        </p:nvSpPr>
-        <p:spPr>
-          <a:xfrm>
-            <a:off x="457200" y="1828800"/>
-            <a:ext cx="5394960" cy="4572000"/>
-          </a:xfrm>
-          <a:prstGeom prst="rect">
-            <a:avLst/>
-          </a:prstGeom>
-          <a:noFill/>
-        </p:spPr>
-        <p:txBody>
-          <a:bodyPr wrap="square">
-            <a:spAutoFit/>
-          </a:bodyPr>
-          <a:lstStyle/>
-          <a:p>
-            <a:pPr algn="l">
-              <a:lnSpc>
-                <a:spcPct val="140000"/>
-              </a:lnSpc>
-              <a:spcAft>
-                <a:spcPts val="800"/>
-              </a:spcAft>
-            </a:pPr>
-            <a:r>
-              <a:rPr sz="1400" b="1">
-                <a:solidFill>
-                  <a:srgbClr val="F59E0B"/>
-                </a:solidFill>
-                <a:latin typeface="Calibri"/>
-              </a:rPr>
-              <a:t>● </a:t>
-            </a:r>
-            <a:r>
-              <a:rPr sz="1400">
-                <a:solidFill>
-                  <a:srgbClr val="0F2040"/>
-                </a:solidFill>
-                <a:latin typeface="Calibri"/>
-              </a:rPr>
-              <a:t>15 categorías de permisos documentadas</a:t>
-            </a:r>
-          </a:p>
-          <a:p>
-            <a:pPr algn="l">
-              <a:lnSpc>
-                <a:spcPct val="140000"/>
-              </a:lnSpc>
-              <a:spcAft>
-                <a:spcPts val="800"/>
-              </a:spcAft>
-            </a:pPr>
-            <a:r>
-              <a:rPr sz="1400" b="1">
-                <a:solidFill>
-                  <a:srgbClr val="F59E0B"/>
-                </a:solidFill>
-                <a:latin typeface="Calibri"/>
-              </a:rPr>
-              <a:t>● </a:t>
-            </a:r>
-            <a:r>
-              <a:rPr sz="1400">
-                <a:solidFill>
-                  <a:srgbClr val="0F2040"/>
-                </a:solidFill>
-                <a:latin typeface="Calibri"/>
-              </a:rPr>
-              <a:t>6 roles: admin, supervisor, usuario, personal, auditor, guardia</a:t>
-            </a:r>
-          </a:p>
-          <a:p>
-            <a:pPr algn="l">
-              <a:lnSpc>
-                <a:spcPct val="140000"/>
-              </a:lnSpc>
-              <a:spcAft>
-                <a:spcPts val="800"/>
-              </a:spcAft>
-            </a:pPr>
-            <a:r>
-              <a:rPr sz="1400" b="1">
-                <a:solidFill>
-                  <a:srgbClr val="F59E0B"/>
-                </a:solidFill>
-                <a:latin typeface="Calibri"/>
-              </a:rPr>
-              <a:t>● </a:t>
-            </a:r>
-            <a:r>
-              <a:rPr sz="1400">
-                <a:solidFill>
-                  <a:srgbClr val="0F2040"/>
-                </a:solidFill>
-                <a:latin typeface="Calibri"/>
-              </a:rPr>
-              <a:t>Checkbox "Todos" por categoría</a:t>
-            </a:r>
-          </a:p>
-          <a:p>
-            <a:pPr algn="l">
-              <a:lnSpc>
-                <a:spcPct val="140000"/>
-              </a:lnSpc>
-              <a:spcAft>
-                <a:spcPts val="800"/>
-              </a:spcAft>
-            </a:pPr>
-            <a:r>
-              <a:rPr sz="1400" b="1">
-                <a:solidFill>
-                  <a:srgbClr val="F59E0B"/>
-                </a:solidFill>
-                <a:latin typeface="Calibri"/>
-              </a:rPr>
-              <a:t>● </a:t>
-            </a:r>
-            <a:r>
-              <a:rPr sz="1400">
-                <a:solidFill>
-                  <a:srgbClr val="0F2040"/>
-                </a:solidFill>
-                <a:latin typeface="Calibri"/>
-              </a:rPr>
-              <a:t>Descripción de cada permiso + ID técnico</a:t>
-            </a:r>
-          </a:p>
-          <a:p>
-            <a:pPr algn="l">
-              <a:lnSpc>
-                <a:spcPct val="140000"/>
-              </a:lnSpc>
-              <a:spcAft>
-                <a:spcPts val="800"/>
-              </a:spcAft>
-            </a:pPr>
-            <a:r>
-              <a:rPr sz="1400" b="1">
-                <a:solidFill>
-                  <a:srgbClr val="F59E0B"/>
-                </a:solidFill>
-                <a:latin typeface="Calibri"/>
-              </a:rPr>
-              <a:t>● </a:t>
-            </a:r>
-            <a:r>
-              <a:rPr sz="1400">
-                <a:solidFill>
-                  <a:srgbClr val="0F2040"/>
-                </a:solidFill>
-                <a:latin typeface="Calibri"/>
-              </a:rPr>
-              <a:t>Botón "Restaurar defaults"</a:t>
-            </a:r>
-          </a:p>
-        </p:txBody>
-      </p:sp>
-      <p:sp>
-        <p:nvSpPr>
-          <p:cNvPr id="8" name="Rounded Rectangle 7"/>
-          <p:cNvSpPr/>
-          <p:nvPr/>
-        </p:nvSpPr>
-        <p:spPr>
-          <a:xfrm>
-            <a:off x="6217920" y="1097280"/>
-            <a:ext cx="5577840" cy="548640"/>
-          </a:xfrm>
-          <a:prstGeom prst="roundRect">
-            <a:avLst/>
-          </a:prstGeom>
-          <a:solidFill>
-            <a:srgbClr val="0A1172"/>
-          </a:solidFill>
-          <a:ln>
-            <a:noFill/>
-          </a:ln>
-          <a:effectLst/>
-        </p:spPr>
-        <p:style>
-          <a:lnRef idx="1">
-            <a:schemeClr val="accent1"/>
-          </a:lnRef>
-          <a:fillRef idx="3">
-            <a:schemeClr val="accent1"/>
-          </a:fillRef>
-          <a:effectRef idx="2">
-            <a:schemeClr val="accent1"/>
-          </a:effectRef>
-          <a:fontRef idx="minor">
-            <a:schemeClr val="lt1"/>
-          </a:fontRef>
-        </p:style>
-        <p:txBody>
-          <a:bodyPr rtlCol="0" anchor="ctr"/>
-          <a:lstStyle/>
-          <a:p>
-            <a:pPr algn="ctr"/>
+              <a:t>Asesorías Integrales CyJ · Capacitación Administrador</a:t>
+            </a:r>
           </a:p>
         </p:txBody>
       </p:sp>
       <p:sp>
         <p:nvSpPr>
           <p:cNvPr id="9" name="TextBox 8"/>
-          <p:cNvSpPr txBox="1"/>
-          <p:nvPr/>
-        </p:nvSpPr>
-        <p:spPr>
-          <a:xfrm>
-            <a:off x="6217920" y="1097280"/>
-            <a:ext cx="5577840" cy="548640"/>
-          </a:xfrm>
-          <a:prstGeom prst="rect">
-            <a:avLst/>
-          </a:prstGeom>
-          <a:noFill/>
-        </p:spPr>
-        <p:txBody>
-          <a:bodyPr wrap="square" anchor="ctr" lIns="45720" rIns="45720">
-            <a:spAutoFit/>
-          </a:bodyPr>
-          <a:lstStyle/>
-          <a:p>
-            <a:pPr algn="ctr"/>
-            <a:r>
-              <a:rPr sz="1800" b="1">
-                <a:solidFill>
-                  <a:srgbClr val="FFFFFF"/>
-                </a:solidFill>
-                <a:latin typeface="Calibri"/>
-              </a:rPr>
-              <a:t>Rol admin está bloqueado (locked):</a:t>
-            </a:r>
-          </a:p>
-        </p:txBody>
-      </p:sp>
-      <p:sp>
-        <p:nvSpPr>
-          <p:cNvPr id="10" name="TextBox 9"/>
-          <p:cNvSpPr txBox="1"/>
-          <p:nvPr/>
-        </p:nvSpPr>
-        <p:spPr>
-          <a:xfrm>
-            <a:off x="6309360" y="1828800"/>
-            <a:ext cx="5394960" cy="4572000"/>
-          </a:xfrm>
-          <a:prstGeom prst="rect">
-            <a:avLst/>
-          </a:prstGeom>
-          <a:noFill/>
-        </p:spPr>
-        <p:txBody>
-          <a:bodyPr wrap="square">
-            <a:spAutoFit/>
-          </a:bodyPr>
-          <a:lstStyle/>
-          <a:p>
-            <a:pPr algn="l">
-              <a:lnSpc>
-                <a:spcPct val="140000"/>
-              </a:lnSpc>
-              <a:spcAft>
-                <a:spcPts val="800"/>
-              </a:spcAft>
-            </a:pPr>
-            <a:r>
-              <a:rPr sz="1400" b="1">
-                <a:solidFill>
-                  <a:srgbClr val="0A1172"/>
-                </a:solidFill>
-                <a:latin typeface="Calibri"/>
-              </a:rPr>
-              <a:t>● </a:t>
-            </a:r>
-            <a:r>
-              <a:rPr sz="1400">
-                <a:solidFill>
-                  <a:srgbClr val="0F2040"/>
-                </a:solidFill>
-                <a:latin typeface="Calibri"/>
-              </a:rPr>
-              <a:t>Los permisos del admin NO se pueden modificar desde la UI</a:t>
-            </a:r>
-          </a:p>
-          <a:p>
-            <a:pPr algn="l">
-              <a:lnSpc>
-                <a:spcPct val="140000"/>
-              </a:lnSpc>
-              <a:spcAft>
-                <a:spcPts val="800"/>
-              </a:spcAft>
-            </a:pPr>
-            <a:r>
-              <a:rPr sz="1400" b="1">
-                <a:solidFill>
-                  <a:srgbClr val="0A1172"/>
-                </a:solidFill>
-                <a:latin typeface="Calibri"/>
-              </a:rPr>
-              <a:t>● </a:t>
-            </a:r>
-            <a:r>
-              <a:rPr sz="1400">
-                <a:solidFill>
-                  <a:srgbClr val="0F2040"/>
-                </a:solidFill>
-                <a:latin typeface="Calibri"/>
-              </a:rPr>
-              <a:t>Por seguridad, el admin siempre tiene acceso total</a:t>
-            </a:r>
-          </a:p>
-          <a:p>
-            <a:pPr algn="l">
-              <a:lnSpc>
-                <a:spcPct val="140000"/>
-              </a:lnSpc>
-              <a:spcAft>
-                <a:spcPts val="800"/>
-              </a:spcAft>
-            </a:pPr>
-            <a:r>
-              <a:rPr sz="1400" b="1">
-                <a:solidFill>
-                  <a:srgbClr val="0A1172"/>
-                </a:solidFill>
-                <a:latin typeface="Calibri"/>
-              </a:rPr>
-              <a:t>● </a:t>
-            </a:r>
-            <a:r>
-              <a:rPr sz="1400">
-                <a:solidFill>
-                  <a:srgbClr val="0F2040"/>
-                </a:solidFill>
-                <a:latin typeface="Calibri"/>
-              </a:rPr>
-              <a:t>Para cambiar permisos de admin: editar código en lib/auth.ts</a:t>
-            </a:r>
-          </a:p>
-          <a:p>
-            <a:pPr algn="l">
-              <a:lnSpc>
-                <a:spcPct val="140000"/>
-              </a:lnSpc>
-              <a:spcAft>
-                <a:spcPts val="800"/>
-              </a:spcAft>
-            </a:pPr>
-            <a:r>
-              <a:rPr sz="1400" b="1">
-                <a:solidFill>
-                  <a:srgbClr val="0A1172"/>
-                </a:solidFill>
-                <a:latin typeface="Calibri"/>
-              </a:rPr>
-              <a:t>● </a:t>
-            </a:r>
-            <a:r>
-              <a:rPr sz="1400">
-                <a:solidFill>
-                  <a:srgbClr val="0F2040"/>
-                </a:solidFill>
-                <a:latin typeface="Calibri"/>
-              </a:rPr>
-              <a:t>Usuarios individuales pueden tener permisos personalizados</a:t>
-            </a:r>
-          </a:p>
-          <a:p>
-            <a:pPr algn="l">
-              <a:lnSpc>
-                <a:spcPct val="140000"/>
-              </a:lnSpc>
-              <a:spcAft>
-                <a:spcPts val="800"/>
-              </a:spcAft>
-            </a:pPr>
-            <a:r>
-              <a:rPr sz="1400" b="1">
-                <a:solidFill>
-                  <a:srgbClr val="0A1172"/>
-                </a:solidFill>
-                <a:latin typeface="Calibri"/>
-              </a:rPr>
-              <a:t>● </a:t>
-            </a:r>
-            <a:r>
-              <a:rPr sz="1400">
-                <a:solidFill>
-                  <a:srgbClr val="0F2040"/>
-                </a:solidFill>
-                <a:latin typeface="Calibri"/>
-              </a:rPr>
-              <a:t>Los cambios aplican a nuevos usuarios creados</a:t>
-            </a:r>
-          </a:p>
-        </p:txBody>
-      </p:sp>
-      <p:sp>
-        <p:nvSpPr>
-          <p:cNvPr id="11" name="Rectangle 10"/>
-          <p:cNvSpPr/>
-          <p:nvPr/>
-        </p:nvSpPr>
-        <p:spPr>
-          <a:xfrm>
-            <a:off x="0" y="6583680"/>
-            <a:ext cx="12191695" cy="274320"/>
-          </a:xfrm>
-          <a:prstGeom prst="rect">
-            <a:avLst/>
-          </a:prstGeom>
-          <a:solidFill>
-            <a:srgbClr val="0F2040"/>
-          </a:solidFill>
-          <a:ln>
-            <a:noFill/>
-          </a:ln>
-          <a:effectLst/>
-        </p:spPr>
-        <p:style>
-          <a:lnRef idx="1">
-            <a:schemeClr val="accent1"/>
-          </a:lnRef>
-          <a:fillRef idx="3">
-            <a:schemeClr val="accent1"/>
-          </a:fillRef>
-          <a:effectRef idx="2">
-            <a:schemeClr val="accent1"/>
-          </a:effectRef>
-          <a:fontRef idx="minor">
-            <a:schemeClr val="lt1"/>
-          </a:fontRef>
-        </p:style>
-        <p:txBody>
-          <a:bodyPr rtlCol="0" anchor="ctr"/>
-          <a:lstStyle/>
-          <a:p>
-            <a:pPr algn="ctr"/>
-          </a:p>
-        </p:txBody>
-      </p:sp>
-      <p:sp>
-        <p:nvSpPr>
-          <p:cNvPr id="12" name="TextBox 11"/>
-          <p:cNvSpPr txBox="1"/>
-          <p:nvPr/>
-        </p:nvSpPr>
-        <p:spPr>
-          <a:xfrm>
-            <a:off x="365760" y="6583680"/>
-            <a:ext cx="6400800" cy="274320"/>
-          </a:xfrm>
-          <a:prstGeom prst="rect">
-            <a:avLst/>
-          </a:prstGeom>
-          <a:noFill/>
-        </p:spPr>
-        <p:txBody>
-          <a:bodyPr wrap="square" anchor="ctr" lIns="45720" rIns="45720">
-            <a:spAutoFit/>
-          </a:bodyPr>
-          <a:lstStyle/>
-          <a:p>
-            <a:pPr algn="l"/>
-            <a:r>
-              <a:rPr sz="900" b="0">
-                <a:solidFill>
-                  <a:srgbClr val="FFFFFF"/>
-                </a:solidFill>
-                <a:latin typeface="Calibri"/>
-              </a:rPr>
-              <a:t>Asesorías Integrales CyJ · Capacitación Administrador</a:t>
-            </a:r>
-          </a:p>
-        </p:txBody>
-      </p:sp>
-      <p:sp>
-        <p:nvSpPr>
-          <p:cNvPr id="13" name="TextBox 12"/>
           <p:cNvSpPr txBox="1"/>
           <p:nvPr/>
         </p:nvSpPr>
@@ -8185,7 +7930,7 @@
                 </a:solidFill>
                 <a:latin typeface="Calibri"/>
               </a:rPr>
-              <a:t>Gestión de Respaldos</a:t>
+              <a:t>Flujo: Aprobar SC (Etapa 2)</a:t>
             </a:r>
           </a:p>
         </p:txBody>
@@ -8227,20 +7972,260 @@
       </p:sp>
       <p:sp>
         <p:nvSpPr>
-          <p:cNvPr id="5" name="Rounded Rectangle 4"/>
+          <p:cNvPr id="5" name="TextBox 4"/>
+          <p:cNvSpPr txBox="1"/>
+          <p:nvPr/>
+        </p:nvSpPr>
+        <p:spPr>
+          <a:xfrm>
+            <a:off x="457200" y="1005840"/>
+            <a:ext cx="11247120" cy="548640"/>
+          </a:xfrm>
+          <a:prstGeom prst="rect">
+            <a:avLst/>
+          </a:prstGeom>
+          <a:noFill/>
+        </p:spPr>
+        <p:txBody>
+          <a:bodyPr wrap="square" anchor="t" lIns="45720" rIns="45720">
+            <a:spAutoFit/>
+          </a:bodyPr>
+          <a:lstStyle/>
+          <a:p>
+            <a:pPr algn="l"/>
+            <a:r>
+              <a:rPr sz="1400" b="0">
+                <a:solidFill>
+                  <a:srgbClr val="666666"/>
+                </a:solidFill>
+                <a:latin typeface="Calibri"/>
+              </a:rPr>
+              <a:t>Como admin, apruebas en la 2da etapa del flujo:</a:t>
+            </a:r>
+          </a:p>
+        </p:txBody>
+      </p:sp>
+      <p:sp>
+        <p:nvSpPr>
+          <p:cNvPr id="6" name="TextBox 5"/>
+          <p:cNvSpPr txBox="1"/>
+          <p:nvPr/>
+        </p:nvSpPr>
+        <p:spPr>
+          <a:xfrm>
+            <a:off x="640080" y="1645920"/>
+            <a:ext cx="10972800" cy="4572000"/>
+          </a:xfrm>
+          <a:prstGeom prst="rect">
+            <a:avLst/>
+          </a:prstGeom>
+          <a:noFill/>
+        </p:spPr>
+        <p:txBody>
+          <a:bodyPr wrap="square">
+            <a:spAutoFit/>
+          </a:bodyPr>
+          <a:lstStyle/>
+          <a:p>
+            <a:pPr algn="l">
+              <a:lnSpc>
+                <a:spcPct val="150000"/>
+              </a:lnSpc>
+              <a:spcAft>
+                <a:spcPts val="1000"/>
+              </a:spcAft>
+            </a:pPr>
+            <a:r>
+              <a:rPr sz="2000" b="1">
+                <a:solidFill>
+                  <a:srgbClr val="F59E0B"/>
+                </a:solidFill>
+              </a:rPr>
+              <a:t>1.  </a:t>
+            </a:r>
+            <a:r>
+              <a:rPr sz="1600">
+                <a:solidFill>
+                  <a:srgbClr val="0F2040"/>
+                </a:solidFill>
+              </a:rPr>
+              <a:t>Ve a Solicitud de Compras</a:t>
+            </a:r>
+          </a:p>
+          <a:p>
+            <a:pPr algn="l">
+              <a:lnSpc>
+                <a:spcPct val="150000"/>
+              </a:lnSpc>
+              <a:spcAft>
+                <a:spcPts val="1000"/>
+              </a:spcAft>
+            </a:pPr>
+            <a:r>
+              <a:rPr sz="2000" b="1">
+                <a:solidFill>
+                  <a:srgbClr val="F59E0B"/>
+                </a:solidFill>
+              </a:rPr>
+              <a:t>2.  </a:t>
+            </a:r>
+            <a:r>
+              <a:rPr sz="1600">
+                <a:solidFill>
+                  <a:srgbClr val="0F2040"/>
+                </a:solidFill>
+              </a:rPr>
+              <a:t>Busca SC con etapa "Aprobada Supervisor"</a:t>
+            </a:r>
+          </a:p>
+          <a:p>
+            <a:pPr algn="l">
+              <a:lnSpc>
+                <a:spcPct val="150000"/>
+              </a:lnSpc>
+              <a:spcAft>
+                <a:spcPts val="1000"/>
+              </a:spcAft>
+            </a:pPr>
+            <a:r>
+              <a:rPr sz="2000" b="1">
+                <a:solidFill>
+                  <a:srgbClr val="F59E0B"/>
+                </a:solidFill>
+              </a:rPr>
+              <a:t>3.  </a:t>
+            </a:r>
+            <a:r>
+              <a:rPr sz="1600">
+                <a:solidFill>
+                  <a:srgbClr val="0F2040"/>
+                </a:solidFill>
+              </a:rPr>
+              <a:t>Revisa materiales, monto, proveedor sugerido</a:t>
+            </a:r>
+          </a:p>
+          <a:p>
+            <a:pPr algn="l">
+              <a:lnSpc>
+                <a:spcPct val="150000"/>
+              </a:lnSpc>
+              <a:spcAft>
+                <a:spcPts val="1000"/>
+              </a:spcAft>
+            </a:pPr>
+            <a:r>
+              <a:rPr sz="2000" b="1">
+                <a:solidFill>
+                  <a:srgbClr val="F59E0B"/>
+                </a:solidFill>
+              </a:rPr>
+              <a:t>4.  </a:t>
+            </a:r>
+            <a:r>
+              <a:rPr sz="1600">
+                <a:solidFill>
+                  <a:srgbClr val="0F2040"/>
+                </a:solidFill>
+              </a:rPr>
+              <a:t>Haz clic en "Gestionar" (botón verde)</a:t>
+            </a:r>
+          </a:p>
+          <a:p>
+            <a:pPr algn="l">
+              <a:lnSpc>
+                <a:spcPct val="150000"/>
+              </a:lnSpc>
+              <a:spcAft>
+                <a:spcPts val="1000"/>
+              </a:spcAft>
+            </a:pPr>
+            <a:r>
+              <a:rPr sz="2000" b="1">
+                <a:solidFill>
+                  <a:srgbClr val="F59E0B"/>
+                </a:solidFill>
+              </a:rPr>
+              <a:t>5.  </a:t>
+            </a:r>
+            <a:r>
+              <a:rPr sz="1600">
+                <a:solidFill>
+                  <a:srgbClr val="0F2040"/>
+                </a:solidFill>
+              </a:rPr>
+              <a:t>Opcional: agrega observaciones</a:t>
+            </a:r>
+          </a:p>
+          <a:p>
+            <a:pPr algn="l">
+              <a:lnSpc>
+                <a:spcPct val="150000"/>
+              </a:lnSpc>
+              <a:spcAft>
+                <a:spcPts val="1000"/>
+              </a:spcAft>
+            </a:pPr>
+            <a:r>
+              <a:rPr sz="2000" b="1">
+                <a:solidFill>
+                  <a:srgbClr val="F59E0B"/>
+                </a:solidFill>
+              </a:rPr>
+              <a:t>6.  </a:t>
+            </a:r>
+            <a:r>
+              <a:rPr sz="1600">
+                <a:solidFill>
+                  <a:srgbClr val="0F2040"/>
+                </a:solidFill>
+              </a:rPr>
+              <a:t>Confirma → estado pasa a "En Proceso"</a:t>
+            </a:r>
+          </a:p>
+          <a:p>
+            <a:pPr algn="l">
+              <a:lnSpc>
+                <a:spcPct val="150000"/>
+              </a:lnSpc>
+              <a:spcAft>
+                <a:spcPts val="1000"/>
+              </a:spcAft>
+            </a:pPr>
+            <a:r>
+              <a:rPr sz="2000" b="1">
+                <a:solidFill>
+                  <a:srgbClr val="F59E0B"/>
+                </a:solidFill>
+              </a:rPr>
+              <a:t>7.  </a:t>
+            </a:r>
+            <a:r>
+              <a:rPr sz="1600">
+                <a:solidFill>
+                  <a:srgbClr val="0F2040"/>
+                </a:solidFill>
+              </a:rPr>
+              <a:t>Cuando compres los materiales, edita → estado "Comprado"</a:t>
+            </a:r>
+          </a:p>
+        </p:txBody>
+      </p:sp>
+      <p:sp>
+        <p:nvSpPr>
+          <p:cNvPr id="7" name="Rectangle 6"/>
           <p:cNvSpPr/>
           <p:nvPr/>
         </p:nvSpPr>
         <p:spPr>
           <a:xfrm>
-            <a:off x="914400" y="1828800"/>
-            <a:ext cx="10332720" cy="3200400"/>
-          </a:xfrm>
-          <a:prstGeom prst="roundRect">
+            <a:off x="0" y="6583680"/>
+            <a:ext cx="12191695" cy="274320"/>
+          </a:xfrm>
+          <a:prstGeom prst="rect">
             <a:avLst/>
           </a:prstGeom>
           <a:solidFill>
-            <a:srgbClr val="F1F5F9"/>
+            <a:srgbClr val="0F2040"/>
           </a:solidFill>
           <a:ln>
             <a:noFill/>
@@ -8271,58 +8256,14 @@
       </p:sp>
       <p:sp>
         <p:nvSpPr>
-          <p:cNvPr id="6" name="Rectangle 5"/>
-          <p:cNvSpPr/>
-          <p:nvPr/>
-        </p:nvSpPr>
-        <p:spPr>
-          <a:xfrm>
-            <a:off x="914400" y="1828800"/>
-            <a:ext cx="137160" cy="3200400"/>
-          </a:xfrm>
-          <a:prstGeom prst="rect">
-            <a:avLst/>
-          </a:prstGeom>
-          <a:solidFill>
-            <a:srgbClr val="F59E0B"/>
-          </a:solidFill>
-          <a:ln>
-            <a:noFill/>
-          </a:ln>
-          <a:effectLst/>
-        </p:spPr>
-        <p:style>
-          <a:lnRef idx="1">
-            <a:schemeClr val="accent1"/>
-          </a:lnRef>
-          <a:fillRef idx="3">
-            <a:schemeClr val="accent1"/>
-          </a:fillRef>
-          <a:effectRef idx="2">
-            <a:schemeClr val="accent1"/>
-          </a:effectRef>
-          <a:fontRef idx="minor">
-            <a:schemeClr val="lt1"/>
-          </a:fontRef>
-        </p:style>
-        <p:txBody>
-          <a:bodyPr rtlCol="0" anchor="ctr"/>
-          <a:lstStyle/>
-          <a:p>
-            <a:pPr algn="ctr"/>
-          </a:p>
-        </p:txBody>
-      </p:sp>
-      <p:sp>
-        <p:nvSpPr>
-          <p:cNvPr id="7" name="TextBox 6"/>
+          <p:cNvPr id="8" name="TextBox 7"/>
           <p:cNvSpPr txBox="1"/>
           <p:nvPr/>
         </p:nvSpPr>
         <p:spPr>
           <a:xfrm>
-            <a:off x="1371600" y="2103120"/>
-            <a:ext cx="1828800" cy="1828800"/>
+            <a:off x="365760" y="6583680"/>
+            <a:ext cx="6400800" cy="274320"/>
           </a:xfrm>
           <a:prstGeom prst="rect">
             <a:avLst/>
@@ -8335,128 +8276,14 @@
           </a:bodyPr>
           <a:lstStyle/>
           <a:p>
-            <a:pPr algn="ctr"/>
-            <a:r>
-              <a:rPr sz="8000" b="0">
-                <a:solidFill>
-                  <a:srgbClr val="F59E0B"/>
+            <a:pPr algn="l"/>
+            <a:r>
+              <a:rPr sz="900" b="0">
+                <a:solidFill>
+                  <a:srgbClr val="FFFFFF"/>
                 </a:solidFill>
                 <a:latin typeface="Calibri"/>
               </a:rPr>
-              <a:t>⚠️</a:t>
-            </a:r>
-          </a:p>
-        </p:txBody>
-      </p:sp>
-      <p:sp>
-        <p:nvSpPr>
-          <p:cNvPr id="8" name="TextBox 7"/>
-          <p:cNvSpPr txBox="1"/>
-          <p:nvPr/>
-        </p:nvSpPr>
-        <p:spPr>
-          <a:xfrm>
-            <a:off x="3474720" y="2103120"/>
-            <a:ext cx="7498079" cy="2743200"/>
-          </a:xfrm>
-          <a:prstGeom prst="rect">
-            <a:avLst/>
-          </a:prstGeom>
-          <a:noFill/>
-        </p:spPr>
-        <p:txBody>
-          <a:bodyPr wrap="square" anchor="ctr" lIns="45720" rIns="45720">
-            <a:spAutoFit/>
-          </a:bodyPr>
-          <a:lstStyle/>
-          <a:p>
-            <a:pPr algn="l"/>
-            <a:r>
-              <a:rPr sz="1800" b="0">
-                <a:solidFill>
-                  <a:srgbClr val="0F2040"/>
-                </a:solidFill>
-                <a:latin typeface="Calibri"/>
-              </a:rPr>
-              <a:t>Los respaldos de la base de datos son críticos. Se recomienda hacer al menos un backup semanal y descargarlo a un lugar seguro (no solo en el servidor). Ve a Sistema → Respaldos para crear, descargar o restaurar backups.</a:t>
-            </a:r>
-          </a:p>
-        </p:txBody>
-      </p:sp>
-      <p:sp>
-        <p:nvSpPr>
-          <p:cNvPr id="9" name="Rectangle 8"/>
-          <p:cNvSpPr/>
-          <p:nvPr/>
-        </p:nvSpPr>
-        <p:spPr>
-          <a:xfrm>
-            <a:off x="0" y="6583680"/>
-            <a:ext cx="12191695" cy="274320"/>
-          </a:xfrm>
-          <a:prstGeom prst="rect">
-            <a:avLst/>
-          </a:prstGeom>
-          <a:solidFill>
-            <a:srgbClr val="0F2040"/>
-          </a:solidFill>
-          <a:ln>
-            <a:noFill/>
-          </a:ln>
-          <a:effectLst/>
-        </p:spPr>
-        <p:style>
-          <a:lnRef idx="1">
-            <a:schemeClr val="accent1"/>
-          </a:lnRef>
-          <a:fillRef idx="3">
-            <a:schemeClr val="accent1"/>
-          </a:fillRef>
-          <a:effectRef idx="2">
-            <a:schemeClr val="accent1"/>
-          </a:effectRef>
-          <a:fontRef idx="minor">
-            <a:schemeClr val="lt1"/>
-          </a:fontRef>
-        </p:style>
-        <p:txBody>
-          <a:bodyPr rtlCol="0" anchor="ctr"/>
-          <a:lstStyle/>
-          <a:p>
-            <a:pPr algn="ctr"/>
-          </a:p>
-        </p:txBody>
-      </p:sp>
-      <p:sp>
-        <p:nvSpPr>
-          <p:cNvPr id="10" name="TextBox 9"/>
-          <p:cNvSpPr txBox="1"/>
-          <p:nvPr/>
-        </p:nvSpPr>
-        <p:spPr>
-          <a:xfrm>
-            <a:off x="365760" y="6583680"/>
-            <a:ext cx="6400800" cy="274320"/>
-          </a:xfrm>
-          <a:prstGeom prst="rect">
-            <a:avLst/>
-          </a:prstGeom>
-          <a:noFill/>
-        </p:spPr>
-        <p:txBody>
-          <a:bodyPr wrap="square" anchor="ctr" lIns="45720" rIns="45720">
-            <a:spAutoFit/>
-          </a:bodyPr>
-          <a:lstStyle/>
-          <a:p>
-            <a:pPr algn="l"/>
-            <a:r>
-              <a:rPr sz="900" b="0">
-                <a:solidFill>
-                  <a:srgbClr val="FFFFFF"/>
-                </a:solidFill>
-                <a:latin typeface="Calibri"/>
-              </a:rPr>
               <a:t>Asesorías Integrales CyJ · Capacitación Administrador</a:t>
             </a:r>
           </a:p>
@@ -8464,7 +8291,7 @@
       </p:sp>
       <p:sp>
         <p:nvSpPr>
-          <p:cNvPr id="11" name="TextBox 10"/>
+          <p:cNvPr id="9" name="TextBox 8"/>
           <p:cNvSpPr txBox="1"/>
           <p:nvPr/>
         </p:nvSpPr>

</xml_diff>